<commit_message>
SGD: deck historia — caso sysacad e ilustración de portada (503 + pico de tráfico)
Co-Authored-By: Claude Opus 5.5 (1M context) <noreply@anthropic.com>
</commit_message>
<xml_diff>
--- a/materias/SGD/entregables/serverless/opciones/presentacion-C-historia.pptx
+++ b/materias/SGD/entregables/serverless/opciones/presentacion-C-historia.pptx
@@ -122,7 +122,7 @@
   <p:extLst>
     <p:ext uri="{521415D9-36F7-43E2-AB2F-B90AF26B5E84}">
       <p14:sectionLst xmlns:p14="http://schemas.microsoft.com/office/powerpoint/2010/main">
-        <p14:section name="Expositor 1 — El caso y qué es" id="{25af51f8-9143-4e77-1248-b49a72e2cb43}">
+        <p14:section name="Expositor 1 — El caso y qué es" id="{a30bad5b-f5d9-468c-d485-8b06fd22fd0f}">
           <p14:sldIdLst>
             <p14:sldId id="256"/>
             <p14:sldId id="257"/>
@@ -130,7 +130,7 @@
             <p14:sldId id="259"/>
           </p14:sldIdLst>
         </p14:section>
-        <p14:section name="Expositor 2 — Qué pasa por dentro" id="{e71c4238-ffda-247c-6fc7-85ce9b8f1978}">
+        <p14:section name="Expositor 2 — Qué pasa por dentro" id="{bc12a511-6309-072c-647b-a8d20f302fdb}">
           <p14:sldIdLst>
             <p14:sldId id="260"/>
             <p14:sldId id="261"/>
@@ -138,7 +138,7 @@
             <p14:sldId id="263"/>
           </p14:sldIdLst>
         </p14:section>
-        <p14:section name="Expositor 3 — Costos y base de datos" id="{01b3757b-1163-b654-6901-ccb61e2d2395}">
+        <p14:section name="Expositor 3 — Costos y base de datos" id="{5dac8521-f860-4aef-a383-578f52ff16a4}">
           <p14:sldIdLst>
             <p14:sldId id="264"/>
             <p14:sldId id="265"/>
@@ -146,7 +146,7 @@
             <p14:sldId id="267"/>
           </p14:sldIdLst>
         </p14:section>
-        <p14:section name="Expositor 4 — Cuándo no y cierre" id="{483ed3f0-910c-10d2-5660-2af89712af0b}">
+        <p14:section name="Expositor 4 — Cuándo no y cierre" id="{75173df2-6829-97ca-18ad-bc0d84d1d5cd}">
           <p14:sldIdLst>
             <p14:sldId id="268"/>
             <p14:sldId id="269"/>
@@ -164,6 +164,255 @@
 </file>
 
 <file path=ppt/charts/chart1.xml><?xml version="1.0" encoding="utf-8"?>
+<c:chartSpace xmlns:c="http://schemas.openxmlformats.org/drawingml/2006/chart" xmlns:a="http://schemas.openxmlformats.org/drawingml/2006/main" xmlns:r="http://schemas.openxmlformats.org/officeDocument/2006/relationships">
+  <c:date1904 val="0"/>
+  <c:roundedCorners val="1"/>
+  <c:chart>
+    <c:autoTitleDeleted val="1"/>
+    <c:plotArea>
+      <c:layout/>
+      <c:areaChart>
+        <c:varyColors val="0"/>
+        <c:ser>
+          <c:idx val="0"/>
+          <c:order val="0"/>
+          <c:tx>
+            <c:strRef>
+              <c:f>Sheet1!$B$1</c:f>
+              <c:strCache>
+                <c:ptCount val="1"/>
+                <c:pt idx="0">
+                  <c:v>pedidos</c:v>
+                </c:pt>
+              </c:strCache>
+            </c:strRef>
+          </c:tx>
+          <c:spPr>
+            <a:solidFill>
+              <a:srgbClr val="F2545B">
+                <a:alpha val="85000"/>
+              </a:srgbClr>
+            </a:solidFill>
+            <a:effectLst/>
+          </c:spPr>
+          <c:invertIfNegative val="0"/>
+          <c:dLbls>
+            <c:numFmt formatCode="#,##0" sourceLinked="0"/>
+            <c:txPr>
+              <a:bodyPr/>
+              <a:lstStyle/>
+              <a:p>
+                <a:pPr>
+                  <a:defRPr b="0" i="0" strike="noStrike" sz="1200" u="none">
+                    <a:solidFill>
+                      <a:srgbClr val="000000"/>
+                    </a:solidFill>
+                    <a:latin typeface="Arial"/>
+                  </a:defRPr>
+                </a:pPr>
+              </a:p>
+            </c:txPr>
+            <c:showLegendKey val="0"/>
+            <c:showVal val="0"/>
+            <c:showCatName val="0"/>
+            <c:showSerName val="0"/>
+            <c:showPercent val="0"/>
+            <c:showBubbleSize val="0"/>
+            <c:showLeaderLines val="0"/>
+          </c:dLbls>
+          <c:cat>
+            <c:multiLvlStrRef>
+              <c:f>Sheet1!$A$2:$A$8</c:f>
+              <c:multiLvlStrCache>
+                <c:ptCount val="7"/>
+                <c:lvl>
+                  <c:pt idx="0">
+                    <c:v>06</c:v>
+                  </c:pt>
+                  <c:pt idx="1">
+                    <c:v>07</c:v>
+                  </c:pt>
+                  <c:pt idx="2">
+                    <c:v>08</c:v>
+                  </c:pt>
+                  <c:pt idx="3">
+                    <c:v>09</c:v>
+                  </c:pt>
+                  <c:pt idx="4">
+                    <c:v>10</c:v>
+                  </c:pt>
+                  <c:pt idx="5">
+                    <c:v>11</c:v>
+                  </c:pt>
+                  <c:pt idx="6">
+                    <c:v>12</c:v>
+                  </c:pt>
+                </c:lvl>
+              </c:multiLvlStrCache>
+            </c:multiLvlStrRef>
+          </c:cat>
+          <c:val>
+            <c:numRef>
+              <c:f>Sheet1!$B$2:$B$8</c:f>
+              <c:numCache>
+                <c:formatCode>General</c:formatCode>
+                <c:ptCount val="7"/>
+                <c:pt idx="0">
+                  <c:v>2</c:v>
+                </c:pt>
+                <c:pt idx="1">
+                  <c:v>4</c:v>
+                </c:pt>
+                <c:pt idx="2">
+                  <c:v>100</c:v>
+                </c:pt>
+                <c:pt idx="3">
+                  <c:v>85</c:v>
+                </c:pt>
+                <c:pt idx="4">
+                  <c:v>40</c:v>
+                </c:pt>
+                <c:pt idx="5">
+                  <c:v>15</c:v>
+                </c:pt>
+                <c:pt idx="6">
+                  <c:v>6</c:v>
+                </c:pt>
+              </c:numCache>
+            </c:numRef>
+          </c:val>
+        </c:ser>
+        <c:dLbls>
+          <c:numFmt formatCode="#,##0" sourceLinked="0"/>
+          <c:txPr>
+            <a:bodyPr/>
+            <a:lstStyle/>
+            <a:p>
+              <a:pPr>
+                <a:defRPr b="0" i="0" strike="noStrike" sz="1200" u="none">
+                  <a:solidFill>
+                    <a:srgbClr val="000000"/>
+                  </a:solidFill>
+                  <a:latin typeface="Arial"/>
+                </a:defRPr>
+              </a:pPr>
+            </a:p>
+          </c:txPr>
+          <c:showLegendKey val="0"/>
+          <c:showVal val="0"/>
+          <c:showCatName val="0"/>
+          <c:showSerName val="0"/>
+          <c:showPercent val="0"/>
+          <c:showBubbleSize val="0"/>
+          <c:showLeaderLines val="0"/>
+        </c:dLbls>
+        <c:axId val="2094734554"/>
+        <c:axId val="2094734552"/>
+        <c:axId val="2094734556"/>
+      </c:areaChart>
+      <c:catAx>
+        <c:axId val="2094734554"/>
+        <c:scaling>
+          <c:orientation val="minMax"/>
+        </c:scaling>
+        <c:delete val="0"/>
+        <c:axPos val="b"/>
+        <c:numFmt formatCode="General" sourceLinked="1"/>
+        <c:majorTickMark val="out"/>
+        <c:minorTickMark val="none"/>
+        <c:tickLblPos val="low"/>
+        <c:spPr>
+          <a:ln w="12700" cap="flat">
+            <a:noFill/>
+            <a:prstDash val="solid"/>
+            <a:round/>
+          </a:ln>
+        </c:spPr>
+        <c:txPr>
+          <a:bodyPr/>
+          <a:lstStyle/>
+          <a:p>
+            <a:pPr>
+              <a:defRPr sz="1000" b="0" i="0" u="none" strike="noStrike">
+                <a:solidFill>
+                  <a:srgbClr val="7A7391"/>
+                </a:solidFill>
+                <a:latin typeface="Calibri"/>
+              </a:defRPr>
+            </a:pPr>
+            <a:endParaRPr lang="en-US"/>
+          </a:p>
+        </c:txPr>
+        <c:crossAx val="2094734552"/>
+        <c:crosses val="autoZero"/>
+        <c:auto val="1"/>
+        <c:lblAlgn val="ctr"/>
+        <c:noMultiLvlLbl val="1"/>
+      </c:catAx>
+      <c:valAx>
+        <c:axId val="2094734552"/>
+        <c:scaling>
+          <c:orientation val="minMax"/>
+        </c:scaling>
+        <c:delete val="1"/>
+        <c:axPos val="l"/>
+        <c:numFmt formatCode="General" sourceLinked="0"/>
+        <c:majorTickMark val="out"/>
+        <c:minorTickMark val="none"/>
+        <c:tickLblPos val="nextTo"/>
+        <c:spPr>
+          <a:ln w="12700" cap="flat">
+            <a:solidFill>
+              <a:srgbClr val="888888"/>
+            </a:solidFill>
+            <a:prstDash val="solid"/>
+            <a:round/>
+          </a:ln>
+        </c:spPr>
+        <c:txPr>
+          <a:bodyPr/>
+          <a:lstStyle/>
+          <a:p>
+            <a:pPr>
+              <a:defRPr sz="1200" b="0" i="0" u="none" strike="noStrike">
+                <a:solidFill>
+                  <a:srgbClr val="000000"/>
+                </a:solidFill>
+                <a:latin typeface="Arial"/>
+              </a:defRPr>
+            </a:pPr>
+            <a:endParaRPr lang="en-US"/>
+          </a:p>
+        </c:txPr>
+        <c:crossAx val="2094734554"/>
+        <c:crosses val="autoZero"/>
+        <c:crossBetween val="between"/>
+      </c:valAx>
+      <c:spPr>
+        <a:noFill/>
+        <a:ln>
+          <a:noFill/>
+        </a:ln>
+        <a:effectLst/>
+      </c:spPr>
+    </c:plotArea>
+    <c:plotVisOnly val="1"/>
+    <c:dispBlanksAs val="span"/>
+  </c:chart>
+  <c:spPr>
+    <a:noFill/>
+    <a:ln>
+      <a:noFill/>
+    </a:ln>
+    <a:effectLst/>
+  </c:spPr>
+  <c:externalData r:id="rId1">
+    <c:autoUpdate val="0"/>
+  </c:externalData>
+</c:chartSpace>
+</file>
+
+<file path=ppt/charts/chart2.xml><?xml version="1.0" encoding="utf-8"?>
 <c:chartSpace xmlns:c="http://schemas.openxmlformats.org/drawingml/2006/chart" xmlns:a="http://schemas.openxmlformats.org/drawingml/2006/main" xmlns:r="http://schemas.openxmlformats.org/officeDocument/2006/relationships">
   <c:date1904 val="0"/>
   <c:roundedCorners val="1"/>
@@ -303,7 +552,7 @@
             <c:bubble3D val="0"/>
             <c:spPr>
               <a:solidFill>
-                <a:srgbClr val="D9D0F0"/>
+                <a:srgbClr val="F2545B"/>
               </a:solidFill>
               <a:effectLst/>
             </c:spPr>
@@ -423,10 +672,10 @@
                   <c:v>60</c:v>
                 </c:pt>
                 <c:pt idx="6">
-                  <c:v>20</c:v>
+                  <c:v>30</c:v>
                 </c:pt>
                 <c:pt idx="7">
-                  <c:v>90</c:v>
+                  <c:v>4000</c:v>
                 </c:pt>
                 <c:pt idx="8">
                   <c:v>70</c:v>
@@ -621,7 +870,7 @@
 </c:chartSpace>
 </file>
 
-<file path=ppt/charts/chart2.xml><?xml version="1.0" encoding="utf-8"?>
+<file path=ppt/charts/chart3.xml><?xml version="1.0" encoding="utf-8"?>
 <c:chartSpace xmlns:c="http://schemas.openxmlformats.org/drawingml/2006/chart" xmlns:a="http://schemas.openxmlformats.org/drawingml/2006/main" xmlns:r="http://schemas.openxmlformats.org/officeDocument/2006/relationships">
   <c:date1904 val="0"/>
   <c:roundedCorners val="1"/>
@@ -1563,7 +1812,7 @@
           <a:p>
             <a:r>
               <a:rPr lang="en-US" dirty="0"/>
-              <a:t>[Expositor 1] Buenas, somos el grupo de serverless. En vez de definirlo de entrada, vamos a contarlo con una historia que todos conocemos: el sistema de inscripciones de la facu. Cada uno de nosotros va a responder una pregunta sobre ese caso.</a:t>
+              <a:t>[Expositor 1] Buenas, somos el grupo de serverless. En vez de definirlo de entrada, vamos a contarlo con una historia que todos sufrimos: el SysAcad el día de inscripción a materias. Todo el año anda, y justo el día que lo necesitamos todos, se cae. Cada uno de nosotros va a responder una pregunta sobre ese caso.</a:t>
             </a:r>
             <a:endParaRPr lang="en-US" dirty="0"/>
           </a:p>
@@ -1739,7 +1988,7 @@
           <a:p>
             <a:r>
               <a:rPr lang="en-US" dirty="0"/>
-              <a:t>[Expositor 3] Pero ojo: serverless no es siempre más barato. Normalizado por procesador, el vCPU-hora de Lambda cuesta unas tres veces lo que una instancia equivalente. Las líneas se cruzan cerca del treinta y cuatro por ciento de uso: debajo gana serverless, arriba conviene un servidor. Nuestro sistema de inscripciones está casi todo el año cerca del cero, así que está bien del lado izquierdo.</a:t>
+              <a:t>[Expositor 3] Pero ojo: serverless no es siempre más barato. Normalizado por procesador, el vCPU-hora de Lambda cuesta unas tres veces lo que una instancia equivalente. Las líneas se cruzan cerca del treinta y cuatro por ciento de uso: debajo gana serverless, arriba conviene un servidor. El SysAcad está casi todo el año cerca del cero, así que está bien del lado izquierdo.</a:t>
             </a:r>
             <a:endParaRPr lang="en-US" dirty="0"/>
           </a:p>
@@ -2003,7 +2252,7 @@
           <a:p>
             <a:r>
               <a:rPr lang="en-US" dirty="0"/>
-              <a:t>[Expositor 4] Serverless encaja con cargas espigadas, disparadas por eventos y sin estado, como nuestras inscripciones. No encaja con cargas constantes, latencia crítica o cadenas largas de funciones. El ejemplo más famoso lo dio Amazon: en 2023 el equipo de Prime Video sacó un sistema de monitoreo de serverless, lo pasó a un solo proceso en contenedores y bajó el costo un noventa por ciento, porque lo caro era mover datos entre funciones, no procesarlos.</a:t>
+              <a:t>[Expositor 4] Serverless encaja con cargas espigadas, disparadas por eventos y sin estado, como el SysAcad en inscripción. No encaja con cargas constantes, latencia crítica o cadenas largas de funciones. El ejemplo más famoso lo dio Amazon: en 2023 el equipo de Prime Video sacó un sistema de monitoreo de serverless, lo pasó a un solo proceso en contenedores y bajó el costo un noventa por ciento, porque lo caro era mover datos entre funciones, no procesarlos.</a:t>
             </a:r>
             <a:endParaRPr lang="en-US" dirty="0"/>
           </a:p>
@@ -2179,7 +2428,7 @@
           <a:p>
             <a:r>
               <a:rPr lang="en-US" dirty="0"/>
-              <a:t>[Expositor 4] Volvamos al sistema de inscripciones. Con serverless aguanta el pico, cuesta casi cero el resto del año y lo único que hay que cuidar es la base, con un pooler. Ese es el criterio general: serverless es un trade-off que se elige por encaje con el problema, no por moda. Gracias, ¿preguntas?</a:t>
+              <a:t>[Expositor 4] Volvamos al SysAcad. Si estuviera armado así, aguantaría el pico, costaría casi cero el resto del año y lo único que habría que cuidar es la base, con un pooler. Ese es el criterio general: serverless es un trade-off que se elige por encaje con el problema, no por moda. Gracias, ¿preguntas?</a:t>
             </a:r>
             <a:endParaRPr lang="en-US" dirty="0"/>
           </a:p>
@@ -2267,7 +2516,7 @@
           <a:p>
             <a:r>
               <a:rPr lang="en-US" dirty="0"/>
-              <a:t>[Expositor 1] Este es el caso. El sistema de inscripciones a materias casi no se usa en todo el año, pero el día que abren las inscripciones entran miles de alumnos a la vez y se cae. Los números del gráfico son un escenario ilustrativo, no datos reales de la facu. La pregunta es: ¿cómo dimensionás un sistema así?</a:t>
+              <a:t>[Expositor 1] Este es el caso. El SysAcad se usa poco casi todo el año, pero los días que abre la inscripción a cursado, en marzo y en agosto, entramos miles de alumnos a la vez y se cae. Los números del gráfico son supuestos para el ejemplo, no mediciones del SysAcad real: no conocemos cómo está montado por dentro. La pregunta es: ¿cómo dimensionás un sistema así?</a:t>
             </a:r>
             <a:endParaRPr lang="en-US" dirty="0"/>
           </a:p>
@@ -3615,7 +3864,7 @@
         <p:spPr>
           <a:xfrm>
             <a:off x="548640" y="2880360"/>
-            <a:ext cx="6949440" cy="1005840"/>
+            <a:ext cx="6766560" cy="1005840"/>
           </a:xfrm>
           <a:prstGeom prst="rect">
             <a:avLst/>
@@ -3639,7 +3888,7 @@
                 <a:ea typeface="Cambria" pitchFamily="34" charset="-122"/>
                 <a:cs typeface="Cambria" pitchFamily="34" charset="-120"/>
               </a:rPr>
-              <a:t>La historia de un sistema que se cae un día al año</a:t>
+              <a:t>La historia del SysAcad, que se cae justo el día de la inscripción</a:t>
             </a:r>
             <a:endParaRPr lang="en-US" sz="2600" dirty="0"/>
           </a:p>
@@ -3739,750 +3988,188 @@
       </p:sp>
       <p:sp>
         <p:nvSpPr>
-          <p:cNvPr id="8" name="alumno"/>
-          <p:cNvSpPr/>
-          <p:nvPr/>
-        </p:nvSpPr>
-        <p:spPr>
-          <a:xfrm>
-            <a:off x="8366760" y="1143000"/>
-            <a:ext cx="347472" cy="347472"/>
+          <p:cNvPr id="8" name="navegador"/>
+          <p:cNvSpPr/>
+          <p:nvPr/>
+        </p:nvSpPr>
+        <p:spPr>
+          <a:xfrm>
+            <a:off x="7635240" y="914400"/>
+            <a:ext cx="4023360" cy="4343400"/>
+          </a:xfrm>
+          <a:prstGeom prst="roundRect">
+            <a:avLst>
+              <a:gd name="adj" fmla="val 2727"/>
+            </a:avLst>
+          </a:prstGeom>
+          <a:solidFill>
+            <a:srgbClr val="FFFFFF"/>
+          </a:solidFill>
+          <a:ln/>
+          <a:effectLst>
+            <a:outerShdw sx="100000" sy="100000" kx="0" ky="0" algn="bl" rotWithShape="0" blurRad="152400" dist="50800" dir="5400000">
+              <a:srgbClr val="000000">
+                <a:alpha val="35000"/>
+              </a:srgbClr>
+            </a:outerShdw>
+          </a:effectLst>
+        </p:spPr>
+      </p:sp>
+      <p:sp>
+        <p:nvSpPr>
+          <p:cNvPr id="9" name="barra"/>
+          <p:cNvSpPr/>
+          <p:nvPr/>
+        </p:nvSpPr>
+        <p:spPr>
+          <a:xfrm>
+            <a:off x="7635240" y="914400"/>
+            <a:ext cx="4023360" cy="457200"/>
+          </a:xfrm>
+          <a:prstGeom prst="roundRect">
+            <a:avLst>
+              <a:gd name="adj" fmla="val 24000"/>
+            </a:avLst>
+          </a:prstGeom>
+          <a:solidFill>
+            <a:srgbClr val="F1EDFA"/>
+          </a:solidFill>
+          <a:ln/>
+        </p:spPr>
+      </p:sp>
+      <p:sp>
+        <p:nvSpPr>
+          <p:cNvPr id="10" name="barra-base"/>
+          <p:cNvSpPr/>
+          <p:nvPr/>
+        </p:nvSpPr>
+        <p:spPr>
+          <a:xfrm>
+            <a:off x="7635240" y="1188720"/>
+            <a:ext cx="4023360" cy="182880"/>
+          </a:xfrm>
+          <a:prstGeom prst="rect">
+            <a:avLst/>
+          </a:prstGeom>
+          <a:solidFill>
+            <a:srgbClr val="F1EDFA"/>
+          </a:solidFill>
+          <a:ln/>
+        </p:spPr>
+      </p:sp>
+      <p:sp>
+        <p:nvSpPr>
+          <p:cNvPr id="11" name="punto"/>
+          <p:cNvSpPr/>
+          <p:nvPr/>
+        </p:nvSpPr>
+        <p:spPr>
+          <a:xfrm>
+            <a:off x="7818120" y="1078992"/>
+            <a:ext cx="128016" cy="128016"/>
           </a:xfrm>
           <a:prstGeom prst="ellipse">
             <a:avLst/>
           </a:prstGeom>
           <a:solidFill>
-            <a:srgbClr val="3A2E66"/>
-          </a:solidFill>
-          <a:ln/>
-        </p:spPr>
-      </p:sp>
-      <p:sp>
-        <p:nvSpPr>
-          <p:cNvPr id="9" name="alumno"/>
-          <p:cNvSpPr/>
-          <p:nvPr/>
-        </p:nvSpPr>
-        <p:spPr>
-          <a:xfrm>
-            <a:off x="8915400" y="1143000"/>
-            <a:ext cx="347472" cy="347472"/>
+            <a:srgbClr val="F2545B"/>
+          </a:solidFill>
+          <a:ln/>
+        </p:spPr>
+      </p:sp>
+      <p:sp>
+        <p:nvSpPr>
+          <p:cNvPr id="12" name="punto"/>
+          <p:cNvSpPr/>
+          <p:nvPr/>
+        </p:nvSpPr>
+        <p:spPr>
+          <a:xfrm>
+            <a:off x="8019288" y="1078992"/>
+            <a:ext cx="128016" cy="128016"/>
           </a:xfrm>
           <a:prstGeom prst="ellipse">
             <a:avLst/>
           </a:prstGeom>
           <a:solidFill>
-            <a:srgbClr val="3A2E66"/>
-          </a:solidFill>
-          <a:ln/>
-        </p:spPr>
-      </p:sp>
-      <p:sp>
-        <p:nvSpPr>
-          <p:cNvPr id="10" name="alumno"/>
-          <p:cNvSpPr/>
-          <p:nvPr/>
-        </p:nvSpPr>
-        <p:spPr>
-          <a:xfrm>
-            <a:off x="9464040" y="1143000"/>
-            <a:ext cx="347472" cy="347472"/>
+            <a:srgbClr val="F5B841"/>
+          </a:solidFill>
+          <a:ln/>
+        </p:spPr>
+      </p:sp>
+      <p:sp>
+        <p:nvSpPr>
+          <p:cNvPr id="13" name="punto"/>
+          <p:cNvSpPr/>
+          <p:nvPr/>
+        </p:nvSpPr>
+        <p:spPr>
+          <a:xfrm>
+            <a:off x="8220456" y="1078992"/>
+            <a:ext cx="128016" cy="128016"/>
           </a:xfrm>
           <a:prstGeom prst="ellipse">
             <a:avLst/>
           </a:prstGeom>
           <a:solidFill>
-            <a:srgbClr val="3A2E66"/>
-          </a:solidFill>
-          <a:ln/>
-        </p:spPr>
-      </p:sp>
-      <p:sp>
-        <p:nvSpPr>
-          <p:cNvPr id="11" name="alumno"/>
-          <p:cNvSpPr/>
-          <p:nvPr/>
-        </p:nvSpPr>
-        <p:spPr>
-          <a:xfrm>
-            <a:off x="10012680" y="1143000"/>
-            <a:ext cx="347472" cy="347472"/>
-          </a:xfrm>
-          <a:prstGeom prst="ellipse">
-            <a:avLst/>
-          </a:prstGeom>
-          <a:solidFill>
-            <a:srgbClr val="3A2E66"/>
-          </a:solidFill>
-          <a:ln/>
-        </p:spPr>
-      </p:sp>
-      <p:sp>
-        <p:nvSpPr>
-          <p:cNvPr id="12" name="alumno"/>
-          <p:cNvSpPr/>
-          <p:nvPr/>
-        </p:nvSpPr>
-        <p:spPr>
-          <a:xfrm>
-            <a:off x="10561320" y="1143000"/>
-            <a:ext cx="347472" cy="347472"/>
-          </a:xfrm>
-          <a:prstGeom prst="ellipse">
-            <a:avLst/>
-          </a:prstGeom>
-          <a:solidFill>
-            <a:srgbClr val="3A2E66"/>
-          </a:solidFill>
-          <a:ln/>
-        </p:spPr>
-      </p:sp>
-      <p:sp>
-        <p:nvSpPr>
-          <p:cNvPr id="13" name="alumno"/>
-          <p:cNvSpPr/>
-          <p:nvPr/>
-        </p:nvSpPr>
-        <p:spPr>
-          <a:xfrm>
-            <a:off x="11109960" y="1143000"/>
-            <a:ext cx="347472" cy="347472"/>
-          </a:xfrm>
-          <a:prstGeom prst="ellipse">
-            <a:avLst/>
-          </a:prstGeom>
-          <a:solidFill>
-            <a:srgbClr val="3A2E66"/>
-          </a:solidFill>
-          <a:ln/>
-        </p:spPr>
-      </p:sp>
-      <p:sp>
-        <p:nvSpPr>
-          <p:cNvPr id="14" name="alumno"/>
-          <p:cNvSpPr/>
-          <p:nvPr/>
-        </p:nvSpPr>
-        <p:spPr>
-          <a:xfrm>
-            <a:off x="8366760" y="1691640"/>
-            <a:ext cx="347472" cy="347472"/>
-          </a:xfrm>
-          <a:prstGeom prst="ellipse">
-            <a:avLst/>
-          </a:prstGeom>
-          <a:solidFill>
-            <a:srgbClr val="3A2E66"/>
-          </a:solidFill>
-          <a:ln/>
-        </p:spPr>
-      </p:sp>
-      <p:sp>
-        <p:nvSpPr>
-          <p:cNvPr id="15" name="alumno"/>
-          <p:cNvSpPr/>
-          <p:nvPr/>
-        </p:nvSpPr>
-        <p:spPr>
-          <a:xfrm>
-            <a:off x="8915400" y="1691640"/>
-            <a:ext cx="347472" cy="347472"/>
-          </a:xfrm>
-          <a:prstGeom prst="ellipse">
-            <a:avLst/>
-          </a:prstGeom>
-          <a:solidFill>
-            <a:srgbClr val="3A2E66"/>
-          </a:solidFill>
-          <a:ln/>
-        </p:spPr>
-      </p:sp>
-      <p:sp>
-        <p:nvSpPr>
-          <p:cNvPr id="16" name="alumno"/>
-          <p:cNvSpPr/>
-          <p:nvPr/>
-        </p:nvSpPr>
-        <p:spPr>
-          <a:xfrm>
-            <a:off x="9464040" y="1691640"/>
-            <a:ext cx="347472" cy="347472"/>
-          </a:xfrm>
-          <a:prstGeom prst="ellipse">
-            <a:avLst/>
-          </a:prstGeom>
-          <a:solidFill>
-            <a:srgbClr val="3A2E66"/>
-          </a:solidFill>
-          <a:ln/>
-        </p:spPr>
-      </p:sp>
-      <p:sp>
-        <p:nvSpPr>
-          <p:cNvPr id="17" name="alumno"/>
-          <p:cNvSpPr/>
-          <p:nvPr/>
-        </p:nvSpPr>
-        <p:spPr>
-          <a:xfrm>
-            <a:off x="10012680" y="1691640"/>
-            <a:ext cx="347472" cy="347472"/>
-          </a:xfrm>
-          <a:prstGeom prst="ellipse">
-            <a:avLst/>
-          </a:prstGeom>
-          <a:solidFill>
-            <a:srgbClr val="3A2E66"/>
-          </a:solidFill>
-          <a:ln/>
-        </p:spPr>
-      </p:sp>
-      <p:sp>
-        <p:nvSpPr>
-          <p:cNvPr id="18" name="alumno"/>
-          <p:cNvSpPr/>
-          <p:nvPr/>
-        </p:nvSpPr>
-        <p:spPr>
-          <a:xfrm>
-            <a:off x="10561320" y="1691640"/>
-            <a:ext cx="347472" cy="347472"/>
-          </a:xfrm>
-          <a:prstGeom prst="ellipse">
-            <a:avLst/>
-          </a:prstGeom>
-          <a:solidFill>
-            <a:srgbClr val="3A2E66"/>
-          </a:solidFill>
-          <a:ln/>
-        </p:spPr>
-      </p:sp>
-      <p:sp>
-        <p:nvSpPr>
-          <p:cNvPr id="19" name="alumno"/>
-          <p:cNvSpPr/>
-          <p:nvPr/>
-        </p:nvSpPr>
-        <p:spPr>
-          <a:xfrm>
-            <a:off x="11109960" y="1691640"/>
-            <a:ext cx="347472" cy="347472"/>
-          </a:xfrm>
-          <a:prstGeom prst="ellipse">
-            <a:avLst/>
-          </a:prstGeom>
-          <a:solidFill>
-            <a:srgbClr val="3A2E66"/>
-          </a:solidFill>
-          <a:ln/>
-        </p:spPr>
-      </p:sp>
-      <p:sp>
-        <p:nvSpPr>
-          <p:cNvPr id="20" name="alumno"/>
-          <p:cNvSpPr/>
-          <p:nvPr/>
-        </p:nvSpPr>
-        <p:spPr>
-          <a:xfrm>
-            <a:off x="8366760" y="2240280"/>
-            <a:ext cx="347472" cy="347472"/>
-          </a:xfrm>
-          <a:prstGeom prst="ellipse">
-            <a:avLst/>
-          </a:prstGeom>
-          <a:solidFill>
-            <a:srgbClr val="3A2E66"/>
-          </a:solidFill>
-          <a:ln/>
-        </p:spPr>
-      </p:sp>
-      <p:sp>
-        <p:nvSpPr>
-          <p:cNvPr id="21" name="alumno"/>
-          <p:cNvSpPr/>
-          <p:nvPr/>
-        </p:nvSpPr>
-        <p:spPr>
-          <a:xfrm>
-            <a:off x="8915400" y="2240280"/>
-            <a:ext cx="347472" cy="347472"/>
-          </a:xfrm>
-          <a:prstGeom prst="ellipse">
-            <a:avLst/>
-          </a:prstGeom>
-          <a:solidFill>
-            <a:srgbClr val="3A2E66"/>
-          </a:solidFill>
-          <a:ln/>
-        </p:spPr>
-      </p:sp>
-      <p:sp>
-        <p:nvSpPr>
-          <p:cNvPr id="22" name="alumno"/>
-          <p:cNvSpPr/>
-          <p:nvPr/>
-        </p:nvSpPr>
-        <p:spPr>
-          <a:xfrm>
-            <a:off x="9464040" y="2240280"/>
-            <a:ext cx="347472" cy="347472"/>
-          </a:xfrm>
-          <a:prstGeom prst="ellipse">
-            <a:avLst/>
-          </a:prstGeom>
-          <a:solidFill>
-            <a:srgbClr val="F2545B"/>
-          </a:solidFill>
-          <a:ln/>
-        </p:spPr>
-      </p:sp>
-      <p:sp>
-        <p:nvSpPr>
-          <p:cNvPr id="23" name="alumno"/>
-          <p:cNvSpPr/>
-          <p:nvPr/>
-        </p:nvSpPr>
-        <p:spPr>
-          <a:xfrm>
-            <a:off x="10012680" y="2240280"/>
-            <a:ext cx="347472" cy="347472"/>
-          </a:xfrm>
-          <a:prstGeom prst="ellipse">
-            <a:avLst/>
-          </a:prstGeom>
-          <a:solidFill>
-            <a:srgbClr val="F2545B"/>
-          </a:solidFill>
-          <a:ln/>
-        </p:spPr>
-      </p:sp>
-      <p:sp>
-        <p:nvSpPr>
-          <p:cNvPr id="24" name="alumno"/>
-          <p:cNvSpPr/>
-          <p:nvPr/>
-        </p:nvSpPr>
-        <p:spPr>
-          <a:xfrm>
-            <a:off x="10561320" y="2240280"/>
-            <a:ext cx="347472" cy="347472"/>
-          </a:xfrm>
-          <a:prstGeom prst="ellipse">
-            <a:avLst/>
-          </a:prstGeom>
-          <a:solidFill>
-            <a:srgbClr val="F2545B"/>
-          </a:solidFill>
-          <a:ln/>
-        </p:spPr>
-      </p:sp>
-      <p:sp>
-        <p:nvSpPr>
-          <p:cNvPr id="25" name="alumno"/>
-          <p:cNvSpPr/>
-          <p:nvPr/>
-        </p:nvSpPr>
-        <p:spPr>
-          <a:xfrm>
-            <a:off x="11109960" y="2240280"/>
-            <a:ext cx="347472" cy="347472"/>
-          </a:xfrm>
-          <a:prstGeom prst="ellipse">
-            <a:avLst/>
-          </a:prstGeom>
-          <a:solidFill>
-            <a:srgbClr val="F2545B"/>
-          </a:solidFill>
-          <a:ln/>
-        </p:spPr>
-      </p:sp>
-      <p:sp>
-        <p:nvSpPr>
-          <p:cNvPr id="26" name="alumno"/>
-          <p:cNvSpPr/>
-          <p:nvPr/>
-        </p:nvSpPr>
-        <p:spPr>
-          <a:xfrm>
-            <a:off x="8366760" y="2788920"/>
-            <a:ext cx="347472" cy="347472"/>
-          </a:xfrm>
-          <a:prstGeom prst="ellipse">
-            <a:avLst/>
-          </a:prstGeom>
-          <a:solidFill>
-            <a:srgbClr val="3A2E66"/>
-          </a:solidFill>
-          <a:ln/>
-        </p:spPr>
-      </p:sp>
-      <p:sp>
-        <p:nvSpPr>
-          <p:cNvPr id="27" name="alumno"/>
-          <p:cNvSpPr/>
-          <p:nvPr/>
-        </p:nvSpPr>
-        <p:spPr>
-          <a:xfrm>
-            <a:off x="8915400" y="2788920"/>
-            <a:ext cx="347472" cy="347472"/>
-          </a:xfrm>
-          <a:prstGeom prst="ellipse">
-            <a:avLst/>
-          </a:prstGeom>
-          <a:solidFill>
-            <a:srgbClr val="3A2E66"/>
-          </a:solidFill>
-          <a:ln/>
-        </p:spPr>
-      </p:sp>
-      <p:sp>
-        <p:nvSpPr>
-          <p:cNvPr id="28" name="alumno"/>
-          <p:cNvSpPr/>
-          <p:nvPr/>
-        </p:nvSpPr>
-        <p:spPr>
-          <a:xfrm>
-            <a:off x="9464040" y="2788920"/>
-            <a:ext cx="347472" cy="347472"/>
-          </a:xfrm>
-          <a:prstGeom prst="ellipse">
-            <a:avLst/>
-          </a:prstGeom>
-          <a:solidFill>
-            <a:srgbClr val="F2545B"/>
-          </a:solidFill>
-          <a:ln/>
-        </p:spPr>
-      </p:sp>
-      <p:sp>
-        <p:nvSpPr>
-          <p:cNvPr id="29" name="alumno"/>
-          <p:cNvSpPr/>
-          <p:nvPr/>
-        </p:nvSpPr>
-        <p:spPr>
-          <a:xfrm>
-            <a:off x="10012680" y="2788920"/>
-            <a:ext cx="347472" cy="347472"/>
-          </a:xfrm>
-          <a:prstGeom prst="ellipse">
-            <a:avLst/>
-          </a:prstGeom>
-          <a:solidFill>
-            <a:srgbClr val="F2545B"/>
-          </a:solidFill>
-          <a:ln/>
-        </p:spPr>
-      </p:sp>
-      <p:sp>
-        <p:nvSpPr>
-          <p:cNvPr id="30" name="alumno"/>
-          <p:cNvSpPr/>
-          <p:nvPr/>
-        </p:nvSpPr>
-        <p:spPr>
-          <a:xfrm>
-            <a:off x="10561320" y="2788920"/>
-            <a:ext cx="347472" cy="347472"/>
-          </a:xfrm>
-          <a:prstGeom prst="ellipse">
-            <a:avLst/>
-          </a:prstGeom>
-          <a:solidFill>
-            <a:srgbClr val="F2545B"/>
-          </a:solidFill>
-          <a:ln/>
-        </p:spPr>
-      </p:sp>
-      <p:sp>
-        <p:nvSpPr>
-          <p:cNvPr id="31" name="alumno"/>
-          <p:cNvSpPr/>
-          <p:nvPr/>
-        </p:nvSpPr>
-        <p:spPr>
-          <a:xfrm>
-            <a:off x="11109960" y="2788920"/>
-            <a:ext cx="347472" cy="347472"/>
-          </a:xfrm>
-          <a:prstGeom prst="ellipse">
-            <a:avLst/>
-          </a:prstGeom>
-          <a:solidFill>
-            <a:srgbClr val="F2545B"/>
-          </a:solidFill>
-          <a:ln/>
-        </p:spPr>
-      </p:sp>
-      <p:sp>
-        <p:nvSpPr>
-          <p:cNvPr id="32" name="alumno"/>
-          <p:cNvSpPr/>
-          <p:nvPr/>
-        </p:nvSpPr>
-        <p:spPr>
-          <a:xfrm>
-            <a:off x="8366760" y="3337560"/>
-            <a:ext cx="347472" cy="347472"/>
-          </a:xfrm>
-          <a:prstGeom prst="ellipse">
-            <a:avLst/>
-          </a:prstGeom>
-          <a:solidFill>
-            <a:srgbClr val="3A2E66"/>
-          </a:solidFill>
-          <a:ln/>
-        </p:spPr>
-      </p:sp>
-      <p:sp>
-        <p:nvSpPr>
-          <p:cNvPr id="33" name="alumno"/>
-          <p:cNvSpPr/>
-          <p:nvPr/>
-        </p:nvSpPr>
-        <p:spPr>
-          <a:xfrm>
-            <a:off x="8915400" y="3337560"/>
-            <a:ext cx="347472" cy="347472"/>
-          </a:xfrm>
-          <a:prstGeom prst="ellipse">
-            <a:avLst/>
-          </a:prstGeom>
-          <a:solidFill>
-            <a:srgbClr val="3A2E66"/>
-          </a:solidFill>
-          <a:ln/>
-        </p:spPr>
-      </p:sp>
-      <p:sp>
-        <p:nvSpPr>
-          <p:cNvPr id="34" name="alumno"/>
-          <p:cNvSpPr/>
-          <p:nvPr/>
-        </p:nvSpPr>
-        <p:spPr>
-          <a:xfrm>
-            <a:off x="9464040" y="3337560"/>
-            <a:ext cx="347472" cy="347472"/>
-          </a:xfrm>
-          <a:prstGeom prst="ellipse">
-            <a:avLst/>
-          </a:prstGeom>
-          <a:solidFill>
-            <a:srgbClr val="F2545B"/>
-          </a:solidFill>
-          <a:ln/>
-        </p:spPr>
-      </p:sp>
-      <p:sp>
-        <p:nvSpPr>
-          <p:cNvPr id="35" name="alumno"/>
-          <p:cNvSpPr/>
-          <p:nvPr/>
-        </p:nvSpPr>
-        <p:spPr>
-          <a:xfrm>
-            <a:off x="10012680" y="3337560"/>
-            <a:ext cx="347472" cy="347472"/>
-          </a:xfrm>
-          <a:prstGeom prst="ellipse">
-            <a:avLst/>
-          </a:prstGeom>
-          <a:solidFill>
-            <a:srgbClr val="F2545B"/>
-          </a:solidFill>
-          <a:ln/>
-        </p:spPr>
-      </p:sp>
-      <p:sp>
-        <p:nvSpPr>
-          <p:cNvPr id="36" name="alumno"/>
-          <p:cNvSpPr/>
-          <p:nvPr/>
-        </p:nvSpPr>
-        <p:spPr>
-          <a:xfrm>
-            <a:off x="10561320" y="3337560"/>
-            <a:ext cx="347472" cy="347472"/>
-          </a:xfrm>
-          <a:prstGeom prst="ellipse">
-            <a:avLst/>
-          </a:prstGeom>
-          <a:solidFill>
-            <a:srgbClr val="F2545B"/>
-          </a:solidFill>
-          <a:ln/>
-        </p:spPr>
-      </p:sp>
-      <p:sp>
-        <p:nvSpPr>
-          <p:cNvPr id="37" name="alumno"/>
-          <p:cNvSpPr/>
-          <p:nvPr/>
-        </p:nvSpPr>
-        <p:spPr>
-          <a:xfrm>
-            <a:off x="11109960" y="3337560"/>
-            <a:ext cx="347472" cy="347472"/>
-          </a:xfrm>
-          <a:prstGeom prst="ellipse">
-            <a:avLst/>
-          </a:prstGeom>
-          <a:solidFill>
-            <a:srgbClr val="F2545B"/>
-          </a:solidFill>
-          <a:ln/>
-        </p:spPr>
-      </p:sp>
-      <p:sp>
-        <p:nvSpPr>
-          <p:cNvPr id="38" name="alumno"/>
-          <p:cNvSpPr/>
-          <p:nvPr/>
-        </p:nvSpPr>
-        <p:spPr>
-          <a:xfrm>
-            <a:off x="8366760" y="3886200"/>
-            <a:ext cx="347472" cy="347472"/>
-          </a:xfrm>
-          <a:prstGeom prst="ellipse">
-            <a:avLst/>
-          </a:prstGeom>
-          <a:solidFill>
-            <a:srgbClr val="3A2E66"/>
-          </a:solidFill>
-          <a:ln/>
-        </p:spPr>
-      </p:sp>
-      <p:sp>
-        <p:nvSpPr>
-          <p:cNvPr id="39" name="alumno"/>
-          <p:cNvSpPr/>
-          <p:nvPr/>
-        </p:nvSpPr>
-        <p:spPr>
-          <a:xfrm>
-            <a:off x="8915400" y="3886200"/>
-            <a:ext cx="347472" cy="347472"/>
-          </a:xfrm>
-          <a:prstGeom prst="ellipse">
-            <a:avLst/>
-          </a:prstGeom>
-          <a:solidFill>
-            <a:srgbClr val="3A2E66"/>
-          </a:solidFill>
-          <a:ln/>
-        </p:spPr>
-      </p:sp>
-      <p:sp>
-        <p:nvSpPr>
-          <p:cNvPr id="40" name="alumno"/>
-          <p:cNvSpPr/>
-          <p:nvPr/>
-        </p:nvSpPr>
-        <p:spPr>
-          <a:xfrm>
-            <a:off x="9464040" y="3886200"/>
-            <a:ext cx="347472" cy="347472"/>
-          </a:xfrm>
-          <a:prstGeom prst="ellipse">
-            <a:avLst/>
-          </a:prstGeom>
-          <a:solidFill>
-            <a:srgbClr val="3A2E66"/>
-          </a:solidFill>
-          <a:ln/>
-        </p:spPr>
-      </p:sp>
-      <p:sp>
-        <p:nvSpPr>
-          <p:cNvPr id="41" name="alumno"/>
-          <p:cNvSpPr/>
-          <p:nvPr/>
-        </p:nvSpPr>
-        <p:spPr>
-          <a:xfrm>
-            <a:off x="10012680" y="3886200"/>
-            <a:ext cx="347472" cy="347472"/>
-          </a:xfrm>
-          <a:prstGeom prst="ellipse">
-            <a:avLst/>
-          </a:prstGeom>
-          <a:solidFill>
-            <a:srgbClr val="3A2E66"/>
-          </a:solidFill>
-          <a:ln/>
-        </p:spPr>
-      </p:sp>
-      <p:sp>
-        <p:nvSpPr>
-          <p:cNvPr id="42" name="alumno"/>
-          <p:cNvSpPr/>
-          <p:nvPr/>
-        </p:nvSpPr>
-        <p:spPr>
-          <a:xfrm>
-            <a:off x="10561320" y="3886200"/>
-            <a:ext cx="347472" cy="347472"/>
-          </a:xfrm>
-          <a:prstGeom prst="ellipse">
-            <a:avLst/>
-          </a:prstGeom>
-          <a:solidFill>
-            <a:srgbClr val="3A2E66"/>
-          </a:solidFill>
-          <a:ln/>
-        </p:spPr>
-      </p:sp>
-      <p:sp>
-        <p:nvSpPr>
-          <p:cNvPr id="43" name="alumno"/>
-          <p:cNvSpPr/>
-          <p:nvPr/>
-        </p:nvSpPr>
-        <p:spPr>
-          <a:xfrm>
-            <a:off x="11109960" y="3886200"/>
-            <a:ext cx="347472" cy="347472"/>
-          </a:xfrm>
-          <a:prstGeom prst="ellipse">
-            <a:avLst/>
-          </a:prstGeom>
-          <a:solidFill>
-            <a:srgbClr val="3A2E66"/>
-          </a:solidFill>
-          <a:ln/>
-        </p:spPr>
-      </p:sp>
-      <p:sp>
-        <p:nvSpPr>
-          <p:cNvPr id="44" name="Text 41"/>
-          <p:cNvSpPr txBox="1"/>
-          <p:nvPr/>
-        </p:nvSpPr>
-        <p:spPr>
-          <a:xfrm>
-            <a:off x="8366760" y="4526280"/>
-            <a:ext cx="3291840" cy="365760"/>
-          </a:xfrm>
-          <a:prstGeom prst="rect">
-            <a:avLst/>
-          </a:prstGeom>
-          <a:noFill/>
-          <a:ln/>
-        </p:spPr>
-        <p:txBody>
-          <a:bodyPr wrap="square" lIns="0" tIns="0" rIns="0" bIns="0" rtlCol="0" anchor="t"/>
+            <a:srgbClr val="5BC27A"/>
+          </a:solidFill>
+          <a:ln/>
+        </p:spPr>
+      </p:sp>
+      <p:sp>
+        <p:nvSpPr>
+          <p:cNvPr id="14" name="url"/>
+          <p:cNvSpPr/>
+          <p:nvPr/>
+        </p:nvSpPr>
+        <p:spPr>
+          <a:xfrm>
+            <a:off x="8503920" y="1014984"/>
+            <a:ext cx="2971800" cy="256032"/>
+          </a:xfrm>
+          <a:prstGeom prst="roundRect">
+            <a:avLst>
+              <a:gd name="adj" fmla="val 50000"/>
+            </a:avLst>
+          </a:prstGeom>
+          <a:solidFill>
+            <a:srgbClr val="FFFFFF"/>
+          </a:solidFill>
+          <a:ln w="9525">
+            <a:solidFill>
+              <a:srgbClr val="D9D0F0"/>
+            </a:solidFill>
+            <a:prstDash val="solid"/>
+          </a:ln>
+        </p:spPr>
+      </p:sp>
+      <p:sp>
+        <p:nvSpPr>
+          <p:cNvPr id="15" name="Text 12"/>
+          <p:cNvSpPr txBox="1"/>
+          <p:nvPr/>
+        </p:nvSpPr>
+        <p:spPr>
+          <a:xfrm>
+            <a:off x="8641080" y="1014984"/>
+            <a:ext cx="2743200" cy="256032"/>
+          </a:xfrm>
+          <a:prstGeom prst="rect">
+            <a:avLst/>
+          </a:prstGeom>
+          <a:noFill/>
+          <a:ln/>
+        </p:spPr>
+        <p:txBody>
+          <a:bodyPr wrap="square" lIns="0" tIns="0" rIns="0" bIns="0" rtlCol="0" anchor="ctr"/>
           <a:lstStyle/>
           <a:p>
             <a:pPr indent="0" marL="0">
               <a:buNone/>
             </a:pPr>
             <a:r>
-              <a:rPr lang="en-US" sz="1200" i="1" dirty="0">
+              <a:rPr lang="en-US" sz="1000" dirty="0">
                 <a:solidFill>
                   <a:srgbClr val="7A7391"/>
                 </a:solidFill>
@@ -4490,9 +4177,374 @@
                 <a:ea typeface="Calibri" pitchFamily="34" charset="-122"/>
                 <a:cs typeface="Calibri" pitchFamily="34" charset="-120"/>
               </a:rPr>
-              <a:t>Un día al año, todos a la vez</a:t>
-            </a:r>
-            <a:endParaRPr lang="en-US" sz="1200" dirty="0"/>
+              <a:t>sysacad · inscripción a cursado</a:t>
+            </a:r>
+            <a:endParaRPr lang="en-US" sz="1000" dirty="0"/>
+          </a:p>
+        </p:txBody>
+      </p:sp>
+      <p:sp>
+        <p:nvSpPr>
+          <p:cNvPr id="16" name="Text 13"/>
+          <p:cNvSpPr txBox="1"/>
+          <p:nvPr/>
+        </p:nvSpPr>
+        <p:spPr>
+          <a:xfrm>
+            <a:off x="7955280" y="1554480"/>
+            <a:ext cx="2011680" cy="914400"/>
+          </a:xfrm>
+          <a:prstGeom prst="rect">
+            <a:avLst/>
+          </a:prstGeom>
+          <a:noFill/>
+          <a:ln/>
+        </p:spPr>
+        <p:txBody>
+          <a:bodyPr wrap="square" lIns="0" tIns="0" rIns="0" bIns="0" rtlCol="0" anchor="ctr"/>
+          <a:lstStyle/>
+          <a:p>
+            <a:pPr indent="0" marL="0">
+              <a:buNone/>
+            </a:pPr>
+            <a:r>
+              <a:rPr lang="en-US" sz="6000" b="1" dirty="0">
+                <a:solidFill>
+                  <a:srgbClr val="F2545B"/>
+                </a:solidFill>
+                <a:latin typeface="Cambria" pitchFamily="34" charset="0"/>
+                <a:ea typeface="Cambria" pitchFamily="34" charset="-122"/>
+                <a:cs typeface="Cambria" pitchFamily="34" charset="-120"/>
+              </a:rPr>
+              <a:t>503</a:t>
+            </a:r>
+            <a:endParaRPr lang="en-US" sz="6000" dirty="0"/>
+          </a:p>
+        </p:txBody>
+      </p:sp>
+      <p:sp>
+        <p:nvSpPr>
+          <p:cNvPr id="17" name="Text 14"/>
+          <p:cNvSpPr txBox="1"/>
+          <p:nvPr/>
+        </p:nvSpPr>
+        <p:spPr>
+          <a:xfrm>
+            <a:off x="7955280" y="2514600"/>
+            <a:ext cx="3383280" cy="731520"/>
+          </a:xfrm>
+          <a:prstGeom prst="rect">
+            <a:avLst/>
+          </a:prstGeom>
+          <a:noFill/>
+          <a:ln/>
+        </p:spPr>
+        <p:txBody>
+          <a:bodyPr wrap="square" lIns="0" tIns="0" rIns="0" bIns="0" rtlCol="0" anchor="t"/>
+          <a:lstStyle/>
+          <a:p>
+            <a:pPr indent="0" marL="0">
+              <a:buNone/>
+            </a:pPr>
+            <a:r>
+              <a:rPr lang="en-US" sz="1500" b="1" dirty="0">
+                <a:solidFill>
+                  <a:srgbClr val="1E1433"/>
+                </a:solidFill>
+                <a:latin typeface="Calibri" pitchFamily="34" charset="0"/>
+                <a:ea typeface="Calibri" pitchFamily="34" charset="-122"/>
+                <a:cs typeface="Calibri" pitchFamily="34" charset="-120"/>
+              </a:rPr>
+              <a:t>Servicio no disponible</a:t>
+            </a:r>
+            <a:endParaRPr lang="en-US" sz="1500" dirty="0"/>
+          </a:p>
+          <a:p>
+            <a:pPr indent="0" marL="0">
+              <a:buNone/>
+            </a:pPr>
+            <a:r>
+              <a:rPr lang="en-US" sz="1200" dirty="0">
+                <a:solidFill>
+                  <a:srgbClr val="4A4560"/>
+                </a:solidFill>
+                <a:latin typeface="Calibri" pitchFamily="34" charset="0"/>
+                <a:ea typeface="Calibri" pitchFamily="34" charset="-122"/>
+                <a:cs typeface="Calibri" pitchFamily="34" charset="-120"/>
+              </a:rPr>
+              <a:t>Demasiados usuarios conectados. Intente más tarde.</a:t>
+            </a:r>
+            <a:endParaRPr lang="en-US" sz="1500" dirty="0"/>
+          </a:p>
+        </p:txBody>
+      </p:sp>
+      <p:sp>
+        <p:nvSpPr>
+          <p:cNvPr id="18" name="spinner"/>
+          <p:cNvSpPr/>
+          <p:nvPr/>
+        </p:nvSpPr>
+        <p:spPr>
+          <a:xfrm>
+            <a:off x="11192256" y="1956816"/>
+            <a:ext cx="109728" cy="109728"/>
+          </a:xfrm>
+          <a:prstGeom prst="ellipse">
+            <a:avLst/>
+          </a:prstGeom>
+          <a:solidFill>
+            <a:srgbClr val="3B1F78">
+              <a:alpha val="90000"/>
+            </a:srgbClr>
+          </a:solidFill>
+          <a:ln/>
+        </p:spPr>
+      </p:sp>
+      <p:sp>
+        <p:nvSpPr>
+          <p:cNvPr id="19" name="spinner"/>
+          <p:cNvSpPr/>
+          <p:nvPr/>
+        </p:nvSpPr>
+        <p:spPr>
+          <a:xfrm>
+            <a:off x="11111910" y="2150790"/>
+            <a:ext cx="109728" cy="109728"/>
+          </a:xfrm>
+          <a:prstGeom prst="ellipse">
+            <a:avLst/>
+          </a:prstGeom>
+          <a:solidFill>
+            <a:srgbClr val="3B1F78">
+              <a:alpha val="79000"/>
+            </a:srgbClr>
+          </a:solidFill>
+          <a:ln/>
+        </p:spPr>
+      </p:sp>
+      <p:sp>
+        <p:nvSpPr>
+          <p:cNvPr id="20" name="spinner"/>
+          <p:cNvSpPr/>
+          <p:nvPr/>
+        </p:nvSpPr>
+        <p:spPr>
+          <a:xfrm>
+            <a:off x="10917936" y="2231136"/>
+            <a:ext cx="109728" cy="109728"/>
+          </a:xfrm>
+          <a:prstGeom prst="ellipse">
+            <a:avLst/>
+          </a:prstGeom>
+          <a:solidFill>
+            <a:srgbClr val="3B1F78">
+              <a:alpha val="68000"/>
+            </a:srgbClr>
+          </a:solidFill>
+          <a:ln/>
+        </p:spPr>
+      </p:sp>
+      <p:sp>
+        <p:nvSpPr>
+          <p:cNvPr id="21" name="spinner"/>
+          <p:cNvSpPr/>
+          <p:nvPr/>
+        </p:nvSpPr>
+        <p:spPr>
+          <a:xfrm>
+            <a:off x="10723962" y="2150790"/>
+            <a:ext cx="109728" cy="109728"/>
+          </a:xfrm>
+          <a:prstGeom prst="ellipse">
+            <a:avLst/>
+          </a:prstGeom>
+          <a:solidFill>
+            <a:srgbClr val="3B1F78">
+              <a:alpha val="57000"/>
+            </a:srgbClr>
+          </a:solidFill>
+          <a:ln/>
+        </p:spPr>
+      </p:sp>
+      <p:sp>
+        <p:nvSpPr>
+          <p:cNvPr id="22" name="spinner"/>
+          <p:cNvSpPr/>
+          <p:nvPr/>
+        </p:nvSpPr>
+        <p:spPr>
+          <a:xfrm>
+            <a:off x="10643616" y="1956816"/>
+            <a:ext cx="109728" cy="109728"/>
+          </a:xfrm>
+          <a:prstGeom prst="ellipse">
+            <a:avLst/>
+          </a:prstGeom>
+          <a:solidFill>
+            <a:srgbClr val="3B1F78">
+              <a:alpha val="46000"/>
+            </a:srgbClr>
+          </a:solidFill>
+          <a:ln/>
+        </p:spPr>
+      </p:sp>
+      <p:sp>
+        <p:nvSpPr>
+          <p:cNvPr id="23" name="spinner"/>
+          <p:cNvSpPr/>
+          <p:nvPr/>
+        </p:nvSpPr>
+        <p:spPr>
+          <a:xfrm>
+            <a:off x="10723962" y="1762842"/>
+            <a:ext cx="109728" cy="109728"/>
+          </a:xfrm>
+          <a:prstGeom prst="ellipse">
+            <a:avLst/>
+          </a:prstGeom>
+          <a:solidFill>
+            <a:srgbClr val="3B1F78">
+              <a:alpha val="35000"/>
+            </a:srgbClr>
+          </a:solidFill>
+          <a:ln/>
+        </p:spPr>
+      </p:sp>
+      <p:sp>
+        <p:nvSpPr>
+          <p:cNvPr id="24" name="spinner"/>
+          <p:cNvSpPr/>
+          <p:nvPr/>
+        </p:nvSpPr>
+        <p:spPr>
+          <a:xfrm>
+            <a:off x="10917936" y="1682496"/>
+            <a:ext cx="109728" cy="109728"/>
+          </a:xfrm>
+          <a:prstGeom prst="ellipse">
+            <a:avLst/>
+          </a:prstGeom>
+          <a:solidFill>
+            <a:srgbClr val="3B1F78">
+              <a:alpha val="24000"/>
+            </a:srgbClr>
+          </a:solidFill>
+          <a:ln/>
+        </p:spPr>
+      </p:sp>
+      <p:sp>
+        <p:nvSpPr>
+          <p:cNvPr id="25" name="spinner"/>
+          <p:cNvSpPr/>
+          <p:nvPr/>
+        </p:nvSpPr>
+        <p:spPr>
+          <a:xfrm>
+            <a:off x="11111910" y="1762842"/>
+            <a:ext cx="109728" cy="109728"/>
+          </a:xfrm>
+          <a:prstGeom prst="ellipse">
+            <a:avLst/>
+          </a:prstGeom>
+          <a:solidFill>
+            <a:srgbClr val="3B1F78">
+              <a:alpha val="13000"/>
+            </a:srgbClr>
+          </a:solidFill>
+          <a:ln/>
+        </p:spPr>
+      </p:sp>
+      <p:graphicFrame>
+        <p:nvGraphicFramePr>
+          <p:cNvPr id="26" name="Chart 0" descr=""/>
+          <p:cNvGraphicFramePr/>
+          <p:nvPr/>
+        </p:nvGraphicFramePr>
+        <p:xfrm>
+          <a:off x="7818120" y="3337560"/>
+          <a:ext cx="3657600" cy="1554480"/>
+        </p:xfrm>
+        <a:graphic xmlns:a="http://schemas.openxmlformats.org/drawingml/2006/main">
+          <a:graphicData uri="http://schemas.openxmlformats.org/drawingml/2006/chart">
+            <c:chart xmlns:c="http://schemas.openxmlformats.org/drawingml/2006/chart" r:id="rId1"/>
+          </a:graphicData>
+        </a:graphic>
+      </p:graphicFrame>
+      <p:sp>
+        <p:nvSpPr>
+          <p:cNvPr id="27" name="Text 23"/>
+          <p:cNvSpPr txBox="1"/>
+          <p:nvPr/>
+        </p:nvSpPr>
+        <p:spPr>
+          <a:xfrm>
+            <a:off x="7955280" y="4873752"/>
+            <a:ext cx="3383280" cy="274320"/>
+          </a:xfrm>
+          <a:prstGeom prst="rect">
+            <a:avLst/>
+          </a:prstGeom>
+          <a:noFill/>
+          <a:ln/>
+        </p:spPr>
+        <p:txBody>
+          <a:bodyPr wrap="square" lIns="0" tIns="0" rIns="0" bIns="0" rtlCol="0" anchor="t"/>
+          <a:lstStyle/>
+          <a:p>
+            <a:pPr indent="0" marL="0">
+              <a:buNone/>
+            </a:pPr>
+            <a:r>
+              <a:rPr lang="en-US" sz="1000" i="1" dirty="0">
+                <a:solidFill>
+                  <a:srgbClr val="7A7391"/>
+                </a:solidFill>
+                <a:latin typeface="Calibri" pitchFamily="34" charset="0"/>
+                <a:ea typeface="Calibri" pitchFamily="34" charset="-122"/>
+                <a:cs typeface="Calibri" pitchFamily="34" charset="-120"/>
+              </a:rPr>
+              <a:t>pedidos por minuto · día de inscripción</a:t>
+            </a:r>
+            <a:endParaRPr lang="en-US" sz="1000" dirty="0"/>
+          </a:p>
+        </p:txBody>
+      </p:sp>
+      <p:sp>
+        <p:nvSpPr>
+          <p:cNvPr id="28" name="Text 24"/>
+          <p:cNvSpPr txBox="1"/>
+          <p:nvPr/>
+        </p:nvSpPr>
+        <p:spPr>
+          <a:xfrm>
+            <a:off x="7635240" y="5367528"/>
+            <a:ext cx="4023360" cy="274320"/>
+          </a:xfrm>
+          <a:prstGeom prst="rect">
+            <a:avLst/>
+          </a:prstGeom>
+          <a:noFill/>
+          <a:ln/>
+        </p:spPr>
+        <p:txBody>
+          <a:bodyPr wrap="square" lIns="0" tIns="0" rIns="0" bIns="0" rtlCol="0" anchor="t"/>
+          <a:lstStyle/>
+          <a:p>
+            <a:pPr algn="r" indent="0" marL="0">
+              <a:buNone/>
+            </a:pPr>
+            <a:r>
+              <a:rPr lang="en-US" sz="1000" i="1" dirty="0">
+                <a:solidFill>
+                  <a:srgbClr val="7A7391"/>
+                </a:solidFill>
+                <a:latin typeface="Calibri" pitchFamily="34" charset="0"/>
+                <a:ea typeface="Calibri" pitchFamily="34" charset="-122"/>
+                <a:cs typeface="Calibri" pitchFamily="34" charset="-120"/>
+              </a:rPr>
+              <a:t>Recreación ilustrativa, no una captura real</a:t>
+            </a:r>
+            <a:endParaRPr lang="en-US" sz="1000" dirty="0"/>
           </a:p>
         </p:txBody>
       </p:sp>
@@ -5827,7 +5879,7 @@
                 <a:ea typeface="Calibri" pitchFamily="34" charset="-122"/>
                 <a:cs typeface="Calibri" pitchFamily="34" charset="-120"/>
               </a:rPr>
-              <a:t>Inscripciones: </a:t>
+              <a:t>SysAcad: </a:t>
             </a:r>
             <a:pPr indent="0" marL="0">
               <a:buNone/>
@@ -9732,7 +9784,7 @@
                 <a:ea typeface="Cambria" pitchFamily="34" charset="-122"/>
                 <a:cs typeface="Cambria" pitchFamily="34" charset="-120"/>
               </a:rPr>
-              <a:t>El sistema de inscripciones, en serverless</a:t>
+              <a:t>El SysAcad, en serverless</a:t>
             </a:r>
             <a:endParaRPr lang="en-US" sz="3000" dirty="0"/>
           </a:p>
@@ -10292,7 +10344,7 @@
                 <a:ea typeface="Cambria" pitchFamily="34" charset="-122"/>
                 <a:cs typeface="Cambria" pitchFamily="34" charset="-120"/>
               </a:rPr>
-              <a:t>Inscripciones: 364 días tranquilos y uno que lo tira todo</a:t>
+              <a:t>SysAcad: tranquilo todo el año, caído el día de inscripción</a:t>
             </a:r>
             <a:endParaRPr lang="en-US" sz="3000" dirty="0"/>
           </a:p>
@@ -10452,7 +10504,7 @@
                 <a:ea typeface="Calibri" pitchFamily="34" charset="-122"/>
                 <a:cs typeface="Calibri" pitchFamily="34" charset="-120"/>
               </a:rPr>
-              <a:t>alumnos a la vez el día que abren las inscripciones</a:t>
+              <a:t>alumnos a la vez el día que abre la inscripción a cursado</a:t>
             </a:r>
             <a:endParaRPr lang="en-US" sz="1500" dirty="0"/>
           </a:p>
@@ -10569,7 +10621,7 @@
                 <a:ea typeface="Calibri" pitchFamily="34" charset="-122"/>
                 <a:cs typeface="Calibri" pitchFamily="34" charset="-120"/>
               </a:rPr>
-              <a:t>Escenario ilustrativo: los números del caso son supuestos para el ejemplo, no datos de la UTN.</a:t>
+              <a:t>Escenario ilustrativo: los números del caso son supuestos para el ejemplo, no mediciones del SysAcad ni datos de la UTN.</a:t>
             </a:r>
             <a:endParaRPr lang="en-US" sz="1000" dirty="0"/>
           </a:p>
@@ -11054,7 +11106,7 @@
                 <a:ea typeface="Calibri" pitchFamily="34" charset="-122"/>
                 <a:cs typeface="Calibri" pitchFamily="34" charset="-120"/>
               </a:rPr>
-              <a:t>Aguanta el día de inscripción, pero 364 días está ocioso y lo pagás igual.</a:t>
+              <a:t>Aguanta la inscripción, pero el resto del año está ocioso y lo pagás igual.</a:t>
             </a:r>
             <a:endParaRPr lang="en-US" sz="1600" dirty="0"/>
           </a:p>

</xml_diff>

<commit_message>
SGD: deck historia — lámina 2 rehecha (503 del sysacad + demanda contra capacidad), portada vuelve a la grilla
Co-Authored-By: Claude Opus 5.5 (1M context) <noreply@anthropic.com>
</commit_message>
<xml_diff>
--- a/materias/SGD/entregables/serverless/opciones/presentacion-C-historia.pptx
+++ b/materias/SGD/entregables/serverless/opciones/presentacion-C-historia.pptx
@@ -122,7 +122,7 @@
   <p:extLst>
     <p:ext uri="{521415D9-36F7-43E2-AB2F-B90AF26B5E84}">
       <p14:sectionLst xmlns:p14="http://schemas.microsoft.com/office/powerpoint/2010/main">
-        <p14:section name="Expositor 1 — El caso y qué es" id="{a30bad5b-f5d9-468c-d485-8b06fd22fd0f}">
+        <p14:section name="Expositor 1 — El caso y qué es" id="{15eab939-ed45-e2af-b867-0787d4f76456}">
           <p14:sldIdLst>
             <p14:sldId id="256"/>
             <p14:sldId id="257"/>
@@ -130,7 +130,7 @@
             <p14:sldId id="259"/>
           </p14:sldIdLst>
         </p14:section>
-        <p14:section name="Expositor 2 — Qué pasa por dentro" id="{bc12a511-6309-072c-647b-a8d20f302fdb}">
+        <p14:section name="Expositor 2 — Qué pasa por dentro" id="{cabb3016-0806-5c6c-d812-5684c33a6943}">
           <p14:sldIdLst>
             <p14:sldId id="260"/>
             <p14:sldId id="261"/>
@@ -138,7 +138,7 @@
             <p14:sldId id="263"/>
           </p14:sldIdLst>
         </p14:section>
-        <p14:section name="Expositor 3 — Costos y base de datos" id="{5dac8521-f860-4aef-a383-578f52ff16a4}">
+        <p14:section name="Expositor 3 — Costos y base de datos" id="{33a2837e-2d46-f7ea-944f-5dfdddabf349}">
           <p14:sldIdLst>
             <p14:sldId id="264"/>
             <p14:sldId id="265"/>
@@ -146,7 +146,7 @@
             <p14:sldId id="267"/>
           </p14:sldIdLst>
         </p14:section>
-        <p14:section name="Expositor 4 — Cuándo no y cierre" id="{75173df2-6829-97ca-18ad-bc0d84d1d5cd}">
+        <p14:section name="Expositor 4 — Cuándo no y cierre" id="{dabf30a5-9edf-43f2-e29c-7ca77a7378f9}">
           <p14:sldIdLst>
             <p14:sldId id="268"/>
             <p14:sldId id="269"/>
@@ -171,7 +171,7 @@
     <c:autoTitleDeleted val="1"/>
     <c:plotArea>
       <c:layout/>
-      <c:areaChart>
+      <c:lineChart>
         <c:varyColors val="0"/>
         <c:ser>
           <c:idx val="0"/>
@@ -182,17 +182,22 @@
               <c:strCache>
                 <c:ptCount val="1"/>
                 <c:pt idx="0">
-                  <c:v>pedidos</c:v>
+                  <c:v>Demanda</c:v>
                 </c:pt>
               </c:strCache>
             </c:strRef>
           </c:tx>
           <c:spPr>
             <a:solidFill>
-              <a:srgbClr val="F2545B">
-                <a:alpha val="85000"/>
-              </a:srgbClr>
+              <a:srgbClr val="F2545B"/>
             </a:solidFill>
+            <a:ln w="38100" cap="flat">
+              <a:solidFill>
+                <a:srgbClr val="F2545B"/>
+              </a:solidFill>
+              <a:prstDash val="solid"/>
+              <a:round/>
+            </a:ln>
             <a:effectLst/>
           </c:spPr>
           <c:invertIfNegative val="0"/>
@@ -220,32 +225,55 @@
             <c:showBubbleSize val="0"/>
             <c:showLeaderLines val="0"/>
           </c:dLbls>
+          <c:marker>
+            <c:symbol val="none"/>
+            <c:size val="6"/>
+            <c:spPr>
+              <a:solidFill>
+                <a:srgbClr val="F2545B"/>
+              </a:solidFill>
+              <a:ln w="9525" cap="flat">
+                <a:solidFill>
+                  <a:srgbClr val="F2545B"/>
+                </a:solidFill>
+                <a:prstDash val="solid"/>
+                <a:round/>
+              </a:ln>
+              <a:effectLst/>
+            </c:spPr>
+          </c:marker>
           <c:cat>
             <c:multiLvlStrRef>
-              <c:f>Sheet1!$A$2:$A$8</c:f>
+              <c:f>Sheet1!$A$2:$A$10</c:f>
               <c:multiLvlStrCache>
-                <c:ptCount val="7"/>
+                <c:ptCount val="9"/>
                 <c:lvl>
                   <c:pt idx="0">
-                    <c:v>06</c:v>
+                    <c:v>06:00</c:v>
                   </c:pt>
                   <c:pt idx="1">
-                    <c:v>07</c:v>
+                    <c:v>07:00</c:v>
                   </c:pt>
                   <c:pt idx="2">
-                    <c:v>08</c:v>
+                    <c:v>08:00</c:v>
                   </c:pt>
                   <c:pt idx="3">
-                    <c:v>09</c:v>
+                    <c:v>09:00</c:v>
                   </c:pt>
                   <c:pt idx="4">
-                    <c:v>10</c:v>
+                    <c:v>10:00</c:v>
                   </c:pt>
                   <c:pt idx="5">
-                    <c:v>11</c:v>
+                    <c:v>11:00</c:v>
                   </c:pt>
                   <c:pt idx="6">
-                    <c:v>12</c:v>
+                    <c:v>12:00</c:v>
+                  </c:pt>
+                  <c:pt idx="7">
+                    <c:v>13:00</c:v>
+                  </c:pt>
+                  <c:pt idx="8">
+                    <c:v>14:00</c:v>
                   </c:pt>
                 </c:lvl>
               </c:multiLvlStrCache>
@@ -253,34 +281,185 @@
           </c:cat>
           <c:val>
             <c:numRef>
-              <c:f>Sheet1!$B$2:$B$8</c:f>
+              <c:f>Sheet1!$B$2:$B$10</c:f>
               <c:numCache>
                 <c:formatCode>General</c:formatCode>
-                <c:ptCount val="7"/>
+                <c:ptCount val="9"/>
                 <c:pt idx="0">
-                  <c:v>2</c:v>
+                  <c:v>5</c:v>
                 </c:pt>
                 <c:pt idx="1">
-                  <c:v>4</c:v>
+                  <c:v>60</c:v>
                 </c:pt>
                 <c:pt idx="2">
-                  <c:v>100</c:v>
+                  <c:v>2000</c:v>
                 </c:pt>
                 <c:pt idx="3">
-                  <c:v>85</c:v>
+                  <c:v>1300</c:v>
                 </c:pt>
                 <c:pt idx="4">
-                  <c:v>40</c:v>
+                  <c:v>450</c:v>
                 </c:pt>
                 <c:pt idx="5">
-                  <c:v>15</c:v>
+                  <c:v>200</c:v>
                 </c:pt>
                 <c:pt idx="6">
-                  <c:v>6</c:v>
+                  <c:v>90</c:v>
+                </c:pt>
+                <c:pt idx="7">
+                  <c:v>60</c:v>
+                </c:pt>
+                <c:pt idx="8">
+                  <c:v>40</c:v>
                 </c:pt>
               </c:numCache>
             </c:numRef>
           </c:val>
+          <c:smooth val="0"/>
+        </c:ser>
+        <c:ser>
+          <c:idx val="1"/>
+          <c:order val="1"/>
+          <c:tx>
+            <c:strRef>
+              <c:f>Sheet1!$C$1</c:f>
+              <c:strCache>
+                <c:ptCount val="1"/>
+                <c:pt idx="0">
+                  <c:v>Capacidad de un servidor dimensionado para el uso normal</c:v>
+                </c:pt>
+              </c:strCache>
+            </c:strRef>
+          </c:tx>
+          <c:spPr>
+            <a:solidFill>
+              <a:srgbClr val="3B1F78"/>
+            </a:solidFill>
+            <a:ln w="38100" cap="flat">
+              <a:solidFill>
+                <a:srgbClr val="3B1F78"/>
+              </a:solidFill>
+              <a:prstDash val="solid"/>
+              <a:round/>
+            </a:ln>
+            <a:effectLst/>
+          </c:spPr>
+          <c:invertIfNegative val="0"/>
+          <c:dLbls>
+            <c:numFmt formatCode="#,##0" sourceLinked="0"/>
+            <c:txPr>
+              <a:bodyPr/>
+              <a:lstStyle/>
+              <a:p>
+                <a:pPr>
+                  <a:defRPr b="0" i="0" strike="noStrike" sz="1200" u="none">
+                    <a:solidFill>
+                      <a:srgbClr val="000000"/>
+                    </a:solidFill>
+                    <a:latin typeface="Arial"/>
+                  </a:defRPr>
+                </a:pPr>
+              </a:p>
+            </c:txPr>
+            <c:showLegendKey val="0"/>
+            <c:showVal val="0"/>
+            <c:showCatName val="0"/>
+            <c:showSerName val="0"/>
+            <c:showPercent val="0"/>
+            <c:showBubbleSize val="0"/>
+            <c:showLeaderLines val="0"/>
+          </c:dLbls>
+          <c:marker>
+            <c:symbol val="none"/>
+            <c:size val="6"/>
+            <c:spPr>
+              <a:solidFill>
+                <a:srgbClr val="3B1F78"/>
+              </a:solidFill>
+              <a:ln w="9525" cap="flat">
+                <a:solidFill>
+                  <a:srgbClr val="3B1F78"/>
+                </a:solidFill>
+                <a:prstDash val="solid"/>
+                <a:round/>
+              </a:ln>
+              <a:effectLst/>
+            </c:spPr>
+          </c:marker>
+          <c:cat>
+            <c:multiLvlStrRef>
+              <c:f>Sheet1!$A$2:$A$10</c:f>
+              <c:multiLvlStrCache>
+                <c:ptCount val="9"/>
+                <c:lvl>
+                  <c:pt idx="0">
+                    <c:v>06:00</c:v>
+                  </c:pt>
+                  <c:pt idx="1">
+                    <c:v>07:00</c:v>
+                  </c:pt>
+                  <c:pt idx="2">
+                    <c:v>08:00</c:v>
+                  </c:pt>
+                  <c:pt idx="3">
+                    <c:v>09:00</c:v>
+                  </c:pt>
+                  <c:pt idx="4">
+                    <c:v>10:00</c:v>
+                  </c:pt>
+                  <c:pt idx="5">
+                    <c:v>11:00</c:v>
+                  </c:pt>
+                  <c:pt idx="6">
+                    <c:v>12:00</c:v>
+                  </c:pt>
+                  <c:pt idx="7">
+                    <c:v>13:00</c:v>
+                  </c:pt>
+                  <c:pt idx="8">
+                    <c:v>14:00</c:v>
+                  </c:pt>
+                </c:lvl>
+              </c:multiLvlStrCache>
+            </c:multiLvlStrRef>
+          </c:cat>
+          <c:val>
+            <c:numRef>
+              <c:f>Sheet1!$C$2:$C$10</c:f>
+              <c:numCache>
+                <c:formatCode>General</c:formatCode>
+                <c:ptCount val="9"/>
+                <c:pt idx="0">
+                  <c:v>400</c:v>
+                </c:pt>
+                <c:pt idx="1">
+                  <c:v>400</c:v>
+                </c:pt>
+                <c:pt idx="2">
+                  <c:v>400</c:v>
+                </c:pt>
+                <c:pt idx="3">
+                  <c:v>400</c:v>
+                </c:pt>
+                <c:pt idx="4">
+                  <c:v>400</c:v>
+                </c:pt>
+                <c:pt idx="5">
+                  <c:v>400</c:v>
+                </c:pt>
+                <c:pt idx="6">
+                  <c:v>400</c:v>
+                </c:pt>
+                <c:pt idx="7">
+                  <c:v>400</c:v>
+                </c:pt>
+                <c:pt idx="8">
+                  <c:v>400</c:v>
+                </c:pt>
+              </c:numCache>
+            </c:numRef>
+          </c:val>
+          <c:smooth val="0"/>
         </c:ser>
         <c:dLbls>
           <c:numFmt formatCode="#,##0" sourceLinked="0"/>
@@ -306,423 +485,11 @@
           <c:showBubbleSize val="0"/>
           <c:showLeaderLines val="0"/>
         </c:dLbls>
+        <c:marker val="1"/>
         <c:axId val="2094734554"/>
         <c:axId val="2094734552"/>
         <c:axId val="2094734556"/>
-      </c:areaChart>
-      <c:catAx>
-        <c:axId val="2094734554"/>
-        <c:scaling>
-          <c:orientation val="minMax"/>
-        </c:scaling>
-        <c:delete val="0"/>
-        <c:axPos val="b"/>
-        <c:numFmt formatCode="General" sourceLinked="1"/>
-        <c:majorTickMark val="out"/>
-        <c:minorTickMark val="none"/>
-        <c:tickLblPos val="low"/>
-        <c:spPr>
-          <a:ln w="12700" cap="flat">
-            <a:noFill/>
-            <a:prstDash val="solid"/>
-            <a:round/>
-          </a:ln>
-        </c:spPr>
-        <c:txPr>
-          <a:bodyPr/>
-          <a:lstStyle/>
-          <a:p>
-            <a:pPr>
-              <a:defRPr sz="1000" b="0" i="0" u="none" strike="noStrike">
-                <a:solidFill>
-                  <a:srgbClr val="7A7391"/>
-                </a:solidFill>
-                <a:latin typeface="Calibri"/>
-              </a:defRPr>
-            </a:pPr>
-            <a:endParaRPr lang="en-US"/>
-          </a:p>
-        </c:txPr>
-        <c:crossAx val="2094734552"/>
-        <c:crosses val="autoZero"/>
-        <c:auto val="1"/>
-        <c:lblAlgn val="ctr"/>
-        <c:noMultiLvlLbl val="1"/>
-      </c:catAx>
-      <c:valAx>
-        <c:axId val="2094734552"/>
-        <c:scaling>
-          <c:orientation val="minMax"/>
-        </c:scaling>
-        <c:delete val="1"/>
-        <c:axPos val="l"/>
-        <c:numFmt formatCode="General" sourceLinked="0"/>
-        <c:majorTickMark val="out"/>
-        <c:minorTickMark val="none"/>
-        <c:tickLblPos val="nextTo"/>
-        <c:spPr>
-          <a:ln w="12700" cap="flat">
-            <a:solidFill>
-              <a:srgbClr val="888888"/>
-            </a:solidFill>
-            <a:prstDash val="solid"/>
-            <a:round/>
-          </a:ln>
-        </c:spPr>
-        <c:txPr>
-          <a:bodyPr/>
-          <a:lstStyle/>
-          <a:p>
-            <a:pPr>
-              <a:defRPr sz="1200" b="0" i="0" u="none" strike="noStrike">
-                <a:solidFill>
-                  <a:srgbClr val="000000"/>
-                </a:solidFill>
-                <a:latin typeface="Arial"/>
-              </a:defRPr>
-            </a:pPr>
-            <a:endParaRPr lang="en-US"/>
-          </a:p>
-        </c:txPr>
-        <c:crossAx val="2094734554"/>
-        <c:crosses val="autoZero"/>
-        <c:crossBetween val="between"/>
-      </c:valAx>
-      <c:spPr>
-        <a:noFill/>
-        <a:ln>
-          <a:noFill/>
-        </a:ln>
-        <a:effectLst/>
-      </c:spPr>
-    </c:plotArea>
-    <c:plotVisOnly val="1"/>
-    <c:dispBlanksAs val="span"/>
-  </c:chart>
-  <c:spPr>
-    <a:noFill/>
-    <a:ln>
-      <a:noFill/>
-    </a:ln>
-    <a:effectLst/>
-  </c:spPr>
-  <c:externalData r:id="rId1">
-    <c:autoUpdate val="0"/>
-  </c:externalData>
-</c:chartSpace>
-</file>
-
-<file path=ppt/charts/chart2.xml><?xml version="1.0" encoding="utf-8"?>
-<c:chartSpace xmlns:c="http://schemas.openxmlformats.org/drawingml/2006/chart" xmlns:a="http://schemas.openxmlformats.org/drawingml/2006/main" xmlns:r="http://schemas.openxmlformats.org/officeDocument/2006/relationships">
-  <c:date1904 val="0"/>
-  <c:roundedCorners val="1"/>
-  <c:chart>
-    <c:autoTitleDeleted val="1"/>
-    <c:plotArea>
-      <c:layout/>
-      <c:barChart>
-        <c:barDir val="col"/>
-        <c:grouping val="clustered"/>
-        <c:varyColors val="0"/>
-        <c:ser>
-          <c:idx val="0"/>
-          <c:order val="0"/>
-          <c:tx>
-            <c:strRef>
-              <c:f>Sheet1!$B$1</c:f>
-              <c:strCache>
-                <c:ptCount val="1"/>
-                <c:pt idx="0">
-                  <c:v>Alumnos simultáneos</c:v>
-                </c:pt>
-              </c:strCache>
-            </c:strRef>
-          </c:tx>
-          <c:spPr>
-            <a:solidFill>
-              <a:srgbClr val="D9D0F0"/>
-            </a:solidFill>
-            <a:effectLst/>
-          </c:spPr>
-          <c:invertIfNegative val="0"/>
-          <c:dLbls>
-            <c:numFmt formatCode="#,##0" sourceLinked="0"/>
-            <c:txPr>
-              <a:bodyPr/>
-              <a:lstStyle/>
-              <a:p>
-                <a:pPr>
-                  <a:defRPr b="0" i="0" strike="noStrike" sz="1200" u="none">
-                    <a:solidFill>
-                      <a:srgbClr val="4A4560"/>
-                    </a:solidFill>
-                    <a:latin typeface="Calibri"/>
-                  </a:defRPr>
-                </a:pPr>
-              </a:p>
-            </c:txPr>
-            <c:showLegendKey val="0"/>
-            <c:showVal val="1"/>
-            <c:showCatName val="0"/>
-            <c:showSerName val="0"/>
-            <c:showPercent val="0"/>
-            <c:showBubbleSize val="0"/>
-            <c:showLeaderLines val="0"/>
-          </c:dLbls>
-          <c:dPt>
-            <c:idx val="0"/>
-            <c:invertIfNegative val="0"/>
-            <c:bubble3D val="0"/>
-            <c:spPr>
-              <a:solidFill>
-                <a:srgbClr val="D9D0F0"/>
-              </a:solidFill>
-              <a:effectLst/>
-            </c:spPr>
-          </c:dPt>
-          <c:dPt>
-            <c:idx val="1"/>
-            <c:invertIfNegative val="0"/>
-            <c:bubble3D val="0"/>
-            <c:spPr>
-              <a:solidFill>
-                <a:srgbClr val="D9D0F0"/>
-              </a:solidFill>
-              <a:effectLst/>
-            </c:spPr>
-          </c:dPt>
-          <c:dPt>
-            <c:idx val="2"/>
-            <c:invertIfNegative val="0"/>
-            <c:bubble3D val="0"/>
-            <c:spPr>
-              <a:solidFill>
-                <a:srgbClr val="F2545B"/>
-              </a:solidFill>
-              <a:effectLst/>
-            </c:spPr>
-          </c:dPt>
-          <c:dPt>
-            <c:idx val="3"/>
-            <c:invertIfNegative val="0"/>
-            <c:bubble3D val="0"/>
-            <c:spPr>
-              <a:solidFill>
-                <a:srgbClr val="D9D0F0"/>
-              </a:solidFill>
-              <a:effectLst/>
-            </c:spPr>
-          </c:dPt>
-          <c:dPt>
-            <c:idx val="4"/>
-            <c:invertIfNegative val="0"/>
-            <c:bubble3D val="0"/>
-            <c:spPr>
-              <a:solidFill>
-                <a:srgbClr val="D9D0F0"/>
-              </a:solidFill>
-              <a:effectLst/>
-            </c:spPr>
-          </c:dPt>
-          <c:dPt>
-            <c:idx val="5"/>
-            <c:invertIfNegative val="0"/>
-            <c:bubble3D val="0"/>
-            <c:spPr>
-              <a:solidFill>
-                <a:srgbClr val="D9D0F0"/>
-              </a:solidFill>
-              <a:effectLst/>
-            </c:spPr>
-          </c:dPt>
-          <c:dPt>
-            <c:idx val="6"/>
-            <c:invertIfNegative val="0"/>
-            <c:bubble3D val="0"/>
-            <c:spPr>
-              <a:solidFill>
-                <a:srgbClr val="D9D0F0"/>
-              </a:solidFill>
-              <a:effectLst/>
-            </c:spPr>
-          </c:dPt>
-          <c:dPt>
-            <c:idx val="7"/>
-            <c:invertIfNegative val="0"/>
-            <c:bubble3D val="0"/>
-            <c:spPr>
-              <a:solidFill>
-                <a:srgbClr val="F2545B"/>
-              </a:solidFill>
-              <a:effectLst/>
-            </c:spPr>
-          </c:dPt>
-          <c:dPt>
-            <c:idx val="8"/>
-            <c:invertIfNegative val="0"/>
-            <c:bubble3D val="0"/>
-            <c:spPr>
-              <a:solidFill>
-                <a:srgbClr val="D9D0F0"/>
-              </a:solidFill>
-              <a:effectLst/>
-            </c:spPr>
-          </c:dPt>
-          <c:dPt>
-            <c:idx val="9"/>
-            <c:invertIfNegative val="0"/>
-            <c:bubble3D val="0"/>
-            <c:spPr>
-              <a:solidFill>
-                <a:srgbClr val="D9D0F0"/>
-              </a:solidFill>
-              <a:effectLst/>
-            </c:spPr>
-          </c:dPt>
-          <c:dPt>
-            <c:idx val="10"/>
-            <c:invertIfNegative val="0"/>
-            <c:bubble3D val="0"/>
-            <c:spPr>
-              <a:solidFill>
-                <a:srgbClr val="D9D0F0"/>
-              </a:solidFill>
-              <a:effectLst/>
-            </c:spPr>
-          </c:dPt>
-          <c:dPt>
-            <c:idx val="11"/>
-            <c:invertIfNegative val="0"/>
-            <c:bubble3D val="0"/>
-            <c:spPr>
-              <a:solidFill>
-                <a:srgbClr val="D9D0F0"/>
-              </a:solidFill>
-              <a:effectLst/>
-            </c:spPr>
-          </c:dPt>
-          <c:cat>
-            <c:multiLvlStrRef>
-              <c:f>Sheet1!$A$2:$A$13</c:f>
-              <c:multiLvlStrCache>
-                <c:ptCount val="12"/>
-                <c:lvl>
-                  <c:pt idx="0">
-                    <c:v>Ene</c:v>
-                  </c:pt>
-                  <c:pt idx="1">
-                    <c:v>Feb</c:v>
-                  </c:pt>
-                  <c:pt idx="2">
-                    <c:v>Mar</c:v>
-                  </c:pt>
-                  <c:pt idx="3">
-                    <c:v>Abr</c:v>
-                  </c:pt>
-                  <c:pt idx="4">
-                    <c:v>May</c:v>
-                  </c:pt>
-                  <c:pt idx="5">
-                    <c:v>Jun</c:v>
-                  </c:pt>
-                  <c:pt idx="6">
-                    <c:v>Jul</c:v>
-                  </c:pt>
-                  <c:pt idx="7">
-                    <c:v>Ago</c:v>
-                  </c:pt>
-                  <c:pt idx="8">
-                    <c:v>Sep</c:v>
-                  </c:pt>
-                  <c:pt idx="9">
-                    <c:v>Oct</c:v>
-                  </c:pt>
-                  <c:pt idx="10">
-                    <c:v>Nov</c:v>
-                  </c:pt>
-                  <c:pt idx="11">
-                    <c:v>Dic</c:v>
-                  </c:pt>
-                </c:lvl>
-              </c:multiLvlStrCache>
-            </c:multiLvlStrRef>
-          </c:cat>
-          <c:val>
-            <c:numRef>
-              <c:f>Sheet1!$B$2:$B$13</c:f>
-              <c:numCache>
-                <c:formatCode>General</c:formatCode>
-                <c:ptCount val="12"/>
-                <c:pt idx="0">
-                  <c:v>10</c:v>
-                </c:pt>
-                <c:pt idx="1">
-                  <c:v>60</c:v>
-                </c:pt>
-                <c:pt idx="2">
-                  <c:v>5000</c:v>
-                </c:pt>
-                <c:pt idx="3">
-                  <c:v>80</c:v>
-                </c:pt>
-                <c:pt idx="4">
-                  <c:v>70</c:v>
-                </c:pt>
-                <c:pt idx="5">
-                  <c:v>60</c:v>
-                </c:pt>
-                <c:pt idx="6">
-                  <c:v>30</c:v>
-                </c:pt>
-                <c:pt idx="7">
-                  <c:v>4000</c:v>
-                </c:pt>
-                <c:pt idx="8">
-                  <c:v>70</c:v>
-                </c:pt>
-                <c:pt idx="9">
-                  <c:v>60</c:v>
-                </c:pt>
-                <c:pt idx="10">
-                  <c:v>50</c:v>
-                </c:pt>
-                <c:pt idx="11">
-                  <c:v>15</c:v>
-                </c:pt>
-              </c:numCache>
-            </c:numRef>
-          </c:val>
-        </c:ser>
-        <c:dLbls>
-          <c:numFmt formatCode="#,##0" sourceLinked="0"/>
-          <c:txPr>
-            <a:bodyPr/>
-            <a:lstStyle/>
-            <a:p>
-              <a:pPr>
-                <a:defRPr b="0" i="0" strike="noStrike" sz="1200" u="none">
-                  <a:solidFill>
-                    <a:srgbClr val="4A4560"/>
-                  </a:solidFill>
-                  <a:latin typeface="Calibri"/>
-                </a:defRPr>
-              </a:pPr>
-            </a:p>
-          </c:txPr>
-          <c:showLegendKey val="0"/>
-          <c:showVal val="1"/>
-          <c:showCatName val="0"/>
-          <c:showSerName val="0"/>
-          <c:showPercent val="0"/>
-          <c:showBubbleSize val="0"/>
-          <c:showLeaderLines val="0"/>
-        </c:dLbls>
-        <c:gapWidth val="45"/>
-        <c:overlap val="0"/>
-        <c:axId val="2094734554"/>
-        <c:axId val="2094734552"/>
-        <c:axId val="2094734556"/>
-      </c:barChart>
+      </c:lineChart>
       <c:catAx>
         <c:axId val="2094734554"/>
         <c:scaling>
@@ -748,9 +515,9 @@
           <a:lstStyle/>
           <a:p>
             <a:pPr>
-              <a:defRPr sz="1300" b="0" i="0" u="none" strike="noStrike">
-                <a:solidFill>
-                  <a:srgbClr val="4A4560"/>
+              <a:defRPr sz="1100" b="0" i="0" u="none" strike="noStrike">
+                <a:solidFill>
+                  <a:srgbClr val="7A7391"/>
                 </a:solidFill>
                 <a:latin typeface="Calibri"/>
               </a:defRPr>
@@ -768,7 +535,7 @@
         <c:axId val="2094734552"/>
         <c:scaling>
           <c:orientation val="minMax"/>
-          <c:max val="6000"/>
+          <c:max val="2200"/>
           <c:min val="0"/>
         </c:scaling>
         <c:delete val="0"/>
@@ -784,36 +551,7 @@
             </a:ln>
           </c:spPr>
         </c:majorGridlines>
-        <c:title>
-          <c:tx>
-            <c:rich>
-              <a:bodyPr/>
-              <a:lstStyle/>
-              <a:p>
-                <a:pPr>
-                  <a:defRPr sz="1100" b="0" i="0" u="none" strike="noStrike">
-                    <a:solidFill>
-                      <a:srgbClr val="7A7391"/>
-                    </a:solidFill>
-                    <a:latin typeface="Calibri"/>
-                  </a:defRPr>
-                </a:pPr>
-                <a:r>
-                  <a:rPr sz="1100" b="0" i="0" u="none" strike="noStrike">
-                    <a:solidFill>
-                      <a:srgbClr val="7A7391"/>
-                    </a:solidFill>
-                    <a:latin typeface="Calibri"/>
-                  </a:rPr>
-                  <a:t>alumnos simultáneos en el pico del mes</a:t>
-                </a:r>
-              </a:p>
-            </c:rich>
-          </c:tx>
-          <c:layout/>
-          <c:overlay val="0"/>
-        </c:title>
-        <c:numFmt formatCode="General" sourceLinked="0"/>
+        <c:numFmt formatCode="0" sourceLinked="0"/>
         <c:majorTickMark val="out"/>
         <c:minorTickMark val="none"/>
         <c:tickLblPos val="nextTo"/>
@@ -844,7 +582,7 @@
         <c:crossAx val="2094734554"/>
         <c:crosses val="autoZero"/>
         <c:crossBetween val="between"/>
-        <c:majorUnit val="1000"/>
+        <c:majorUnit val="500"/>
       </c:valAx>
       <c:spPr>
         <a:noFill/>
@@ -854,6 +592,26 @@
         <a:effectLst/>
       </c:spPr>
     </c:plotArea>
+    <c:legend>
+      <c:legendPos val="t"/>
+      <c:overlay val="0"/>
+      <c:txPr>
+        <a:bodyPr/>
+        <a:lstStyle/>
+        <a:p>
+          <a:pPr>
+            <a:defRPr sz="1200">
+              <a:solidFill>
+                <a:srgbClr val="4A4560"/>
+              </a:solidFill>
+              <a:latin typeface="Calibri"/>
+              <a:cs typeface="Calibri"/>
+            </a:defRPr>
+          </a:pPr>
+          <a:endParaRPr lang="en-US"/>
+        </a:p>
+      </c:txPr>
+    </c:legend>
     <c:plotVisOnly val="1"/>
     <c:dispBlanksAs val="span"/>
   </c:chart>
@@ -870,7 +628,7 @@
 </c:chartSpace>
 </file>
 
-<file path=ppt/charts/chart3.xml><?xml version="1.0" encoding="utf-8"?>
+<file path=ppt/charts/chart2.xml><?xml version="1.0" encoding="utf-8"?>
 <c:chartSpace xmlns:c="http://schemas.openxmlformats.org/drawingml/2006/chart" xmlns:a="http://schemas.openxmlformats.org/drawingml/2006/main" xmlns:r="http://schemas.openxmlformats.org/officeDocument/2006/relationships">
   <c:date1904 val="0"/>
   <c:roundedCorners val="1"/>
@@ -2516,7 +2274,7 @@
           <a:p>
             <a:r>
               <a:rPr lang="en-US" dirty="0"/>
-              <a:t>[Expositor 1] Este es el caso. El SysAcad se usa poco casi todo el año, pero los días que abre la inscripción a cursado, en marzo y en agosto, entramos miles de alumnos a la vez y se cae. Los números del gráfico son supuestos para el ejemplo, no mediciones del SysAcad real: no conocemos cómo está montado por dentro. La pregunta es: ¿cómo dimensionás un sistema así?</a:t>
+              <a:t>[Expositor 1] Esto lo vimos todos: el día que abre la inscripción a cursado entramos al SysAcad y nos encontramos con esto. El gráfico explica por qué. La línea violeta es lo que aguanta un servidor dimensionado para el uso normal; la coral es la demanda de ese día. A las ocho la demanda la supera unas cinco veces, y todo lo que no entra se responde con un error. El resto del año, en cambio, ese servidor está casi ocioso. Los números son supuestos para el ejemplo: no sabemos cómo está montado el SysAcad por dentro.</a:t>
             </a:r>
             <a:endParaRPr lang="en-US" dirty="0"/>
           </a:p>
@@ -3988,90 +3746,299 @@
       </p:sp>
       <p:sp>
         <p:nvSpPr>
-          <p:cNvPr id="8" name="navegador"/>
-          <p:cNvSpPr/>
-          <p:nvPr/>
-        </p:nvSpPr>
-        <p:spPr>
-          <a:xfrm>
-            <a:off x="7635240" y="914400"/>
-            <a:ext cx="4023360" cy="4343400"/>
-          </a:xfrm>
-          <a:prstGeom prst="roundRect">
-            <a:avLst>
-              <a:gd name="adj" fmla="val 2727"/>
-            </a:avLst>
-          </a:prstGeom>
-          <a:solidFill>
-            <a:srgbClr val="FFFFFF"/>
-          </a:solidFill>
-          <a:ln/>
-          <a:effectLst>
-            <a:outerShdw sx="100000" sy="100000" kx="0" ky="0" algn="bl" rotWithShape="0" blurRad="152400" dist="50800" dir="5400000">
-              <a:srgbClr val="000000">
-                <a:alpha val="35000"/>
-              </a:srgbClr>
-            </a:outerShdw>
-          </a:effectLst>
-        </p:spPr>
-      </p:sp>
-      <p:sp>
-        <p:nvSpPr>
-          <p:cNvPr id="9" name="barra"/>
-          <p:cNvSpPr/>
-          <p:nvPr/>
-        </p:nvSpPr>
-        <p:spPr>
-          <a:xfrm>
-            <a:off x="7635240" y="914400"/>
-            <a:ext cx="4023360" cy="457200"/>
-          </a:xfrm>
-          <a:prstGeom prst="roundRect">
-            <a:avLst>
-              <a:gd name="adj" fmla="val 24000"/>
-            </a:avLst>
-          </a:prstGeom>
-          <a:solidFill>
-            <a:srgbClr val="F1EDFA"/>
-          </a:solidFill>
-          <a:ln/>
-        </p:spPr>
-      </p:sp>
-      <p:sp>
-        <p:nvSpPr>
-          <p:cNvPr id="10" name="barra-base"/>
-          <p:cNvSpPr/>
-          <p:nvPr/>
-        </p:nvSpPr>
-        <p:spPr>
-          <a:xfrm>
-            <a:off x="7635240" y="1188720"/>
-            <a:ext cx="4023360" cy="182880"/>
-          </a:xfrm>
-          <a:prstGeom prst="rect">
-            <a:avLst/>
-          </a:prstGeom>
-          <a:solidFill>
-            <a:srgbClr val="F1EDFA"/>
-          </a:solidFill>
-          <a:ln/>
-        </p:spPr>
-      </p:sp>
-      <p:sp>
-        <p:nvSpPr>
-          <p:cNvPr id="11" name="punto"/>
-          <p:cNvSpPr/>
-          <p:nvPr/>
-        </p:nvSpPr>
-        <p:spPr>
-          <a:xfrm>
-            <a:off x="7818120" y="1078992"/>
-            <a:ext cx="128016" cy="128016"/>
+          <p:cNvPr id="8" name="alumno"/>
+          <p:cNvSpPr/>
+          <p:nvPr/>
+        </p:nvSpPr>
+        <p:spPr>
+          <a:xfrm>
+            <a:off x="8366760" y="1143000"/>
+            <a:ext cx="347472" cy="347472"/>
           </a:xfrm>
           <a:prstGeom prst="ellipse">
             <a:avLst/>
           </a:prstGeom>
           <a:solidFill>
+            <a:srgbClr val="3A2E66"/>
+          </a:solidFill>
+          <a:ln/>
+        </p:spPr>
+      </p:sp>
+      <p:sp>
+        <p:nvSpPr>
+          <p:cNvPr id="9" name="alumno"/>
+          <p:cNvSpPr/>
+          <p:nvPr/>
+        </p:nvSpPr>
+        <p:spPr>
+          <a:xfrm>
+            <a:off x="8915400" y="1143000"/>
+            <a:ext cx="347472" cy="347472"/>
+          </a:xfrm>
+          <a:prstGeom prst="ellipse">
+            <a:avLst/>
+          </a:prstGeom>
+          <a:solidFill>
+            <a:srgbClr val="3A2E66"/>
+          </a:solidFill>
+          <a:ln/>
+        </p:spPr>
+      </p:sp>
+      <p:sp>
+        <p:nvSpPr>
+          <p:cNvPr id="10" name="alumno"/>
+          <p:cNvSpPr/>
+          <p:nvPr/>
+        </p:nvSpPr>
+        <p:spPr>
+          <a:xfrm>
+            <a:off x="9464040" y="1143000"/>
+            <a:ext cx="347472" cy="347472"/>
+          </a:xfrm>
+          <a:prstGeom prst="ellipse">
+            <a:avLst/>
+          </a:prstGeom>
+          <a:solidFill>
+            <a:srgbClr val="3A2E66"/>
+          </a:solidFill>
+          <a:ln/>
+        </p:spPr>
+      </p:sp>
+      <p:sp>
+        <p:nvSpPr>
+          <p:cNvPr id="11" name="alumno"/>
+          <p:cNvSpPr/>
+          <p:nvPr/>
+        </p:nvSpPr>
+        <p:spPr>
+          <a:xfrm>
+            <a:off x="10012680" y="1143000"/>
+            <a:ext cx="347472" cy="347472"/>
+          </a:xfrm>
+          <a:prstGeom prst="ellipse">
+            <a:avLst/>
+          </a:prstGeom>
+          <a:solidFill>
+            <a:srgbClr val="3A2E66"/>
+          </a:solidFill>
+          <a:ln/>
+        </p:spPr>
+      </p:sp>
+      <p:sp>
+        <p:nvSpPr>
+          <p:cNvPr id="12" name="alumno"/>
+          <p:cNvSpPr/>
+          <p:nvPr/>
+        </p:nvSpPr>
+        <p:spPr>
+          <a:xfrm>
+            <a:off x="10561320" y="1143000"/>
+            <a:ext cx="347472" cy="347472"/>
+          </a:xfrm>
+          <a:prstGeom prst="ellipse">
+            <a:avLst/>
+          </a:prstGeom>
+          <a:solidFill>
+            <a:srgbClr val="3A2E66"/>
+          </a:solidFill>
+          <a:ln/>
+        </p:spPr>
+      </p:sp>
+      <p:sp>
+        <p:nvSpPr>
+          <p:cNvPr id="13" name="alumno"/>
+          <p:cNvSpPr/>
+          <p:nvPr/>
+        </p:nvSpPr>
+        <p:spPr>
+          <a:xfrm>
+            <a:off x="11109960" y="1143000"/>
+            <a:ext cx="347472" cy="347472"/>
+          </a:xfrm>
+          <a:prstGeom prst="ellipse">
+            <a:avLst/>
+          </a:prstGeom>
+          <a:solidFill>
+            <a:srgbClr val="3A2E66"/>
+          </a:solidFill>
+          <a:ln/>
+        </p:spPr>
+      </p:sp>
+      <p:sp>
+        <p:nvSpPr>
+          <p:cNvPr id="14" name="alumno"/>
+          <p:cNvSpPr/>
+          <p:nvPr/>
+        </p:nvSpPr>
+        <p:spPr>
+          <a:xfrm>
+            <a:off x="8366760" y="1691640"/>
+            <a:ext cx="347472" cy="347472"/>
+          </a:xfrm>
+          <a:prstGeom prst="ellipse">
+            <a:avLst/>
+          </a:prstGeom>
+          <a:solidFill>
+            <a:srgbClr val="3A2E66"/>
+          </a:solidFill>
+          <a:ln/>
+        </p:spPr>
+      </p:sp>
+      <p:sp>
+        <p:nvSpPr>
+          <p:cNvPr id="15" name="alumno"/>
+          <p:cNvSpPr/>
+          <p:nvPr/>
+        </p:nvSpPr>
+        <p:spPr>
+          <a:xfrm>
+            <a:off x="8915400" y="1691640"/>
+            <a:ext cx="347472" cy="347472"/>
+          </a:xfrm>
+          <a:prstGeom prst="ellipse">
+            <a:avLst/>
+          </a:prstGeom>
+          <a:solidFill>
+            <a:srgbClr val="3A2E66"/>
+          </a:solidFill>
+          <a:ln/>
+        </p:spPr>
+      </p:sp>
+      <p:sp>
+        <p:nvSpPr>
+          <p:cNvPr id="16" name="alumno"/>
+          <p:cNvSpPr/>
+          <p:nvPr/>
+        </p:nvSpPr>
+        <p:spPr>
+          <a:xfrm>
+            <a:off x="9464040" y="1691640"/>
+            <a:ext cx="347472" cy="347472"/>
+          </a:xfrm>
+          <a:prstGeom prst="ellipse">
+            <a:avLst/>
+          </a:prstGeom>
+          <a:solidFill>
+            <a:srgbClr val="3A2E66"/>
+          </a:solidFill>
+          <a:ln/>
+        </p:spPr>
+      </p:sp>
+      <p:sp>
+        <p:nvSpPr>
+          <p:cNvPr id="17" name="alumno"/>
+          <p:cNvSpPr/>
+          <p:nvPr/>
+        </p:nvSpPr>
+        <p:spPr>
+          <a:xfrm>
+            <a:off x="10012680" y="1691640"/>
+            <a:ext cx="347472" cy="347472"/>
+          </a:xfrm>
+          <a:prstGeom prst="ellipse">
+            <a:avLst/>
+          </a:prstGeom>
+          <a:solidFill>
+            <a:srgbClr val="3A2E66"/>
+          </a:solidFill>
+          <a:ln/>
+        </p:spPr>
+      </p:sp>
+      <p:sp>
+        <p:nvSpPr>
+          <p:cNvPr id="18" name="alumno"/>
+          <p:cNvSpPr/>
+          <p:nvPr/>
+        </p:nvSpPr>
+        <p:spPr>
+          <a:xfrm>
+            <a:off x="10561320" y="1691640"/>
+            <a:ext cx="347472" cy="347472"/>
+          </a:xfrm>
+          <a:prstGeom prst="ellipse">
+            <a:avLst/>
+          </a:prstGeom>
+          <a:solidFill>
+            <a:srgbClr val="3A2E66"/>
+          </a:solidFill>
+          <a:ln/>
+        </p:spPr>
+      </p:sp>
+      <p:sp>
+        <p:nvSpPr>
+          <p:cNvPr id="19" name="alumno"/>
+          <p:cNvSpPr/>
+          <p:nvPr/>
+        </p:nvSpPr>
+        <p:spPr>
+          <a:xfrm>
+            <a:off x="11109960" y="1691640"/>
+            <a:ext cx="347472" cy="347472"/>
+          </a:xfrm>
+          <a:prstGeom prst="ellipse">
+            <a:avLst/>
+          </a:prstGeom>
+          <a:solidFill>
+            <a:srgbClr val="3A2E66"/>
+          </a:solidFill>
+          <a:ln/>
+        </p:spPr>
+      </p:sp>
+      <p:sp>
+        <p:nvSpPr>
+          <p:cNvPr id="20" name="alumno"/>
+          <p:cNvSpPr/>
+          <p:nvPr/>
+        </p:nvSpPr>
+        <p:spPr>
+          <a:xfrm>
+            <a:off x="8366760" y="2240280"/>
+            <a:ext cx="347472" cy="347472"/>
+          </a:xfrm>
+          <a:prstGeom prst="ellipse">
+            <a:avLst/>
+          </a:prstGeom>
+          <a:solidFill>
+            <a:srgbClr val="3A2E66"/>
+          </a:solidFill>
+          <a:ln/>
+        </p:spPr>
+      </p:sp>
+      <p:sp>
+        <p:nvSpPr>
+          <p:cNvPr id="21" name="alumno"/>
+          <p:cNvSpPr/>
+          <p:nvPr/>
+        </p:nvSpPr>
+        <p:spPr>
+          <a:xfrm>
+            <a:off x="8915400" y="2240280"/>
+            <a:ext cx="347472" cy="347472"/>
+          </a:xfrm>
+          <a:prstGeom prst="ellipse">
+            <a:avLst/>
+          </a:prstGeom>
+          <a:solidFill>
+            <a:srgbClr val="3A2E66"/>
+          </a:solidFill>
+          <a:ln/>
+        </p:spPr>
+      </p:sp>
+      <p:sp>
+        <p:nvSpPr>
+          <p:cNvPr id="22" name="alumno"/>
+          <p:cNvSpPr/>
+          <p:nvPr/>
+        </p:nvSpPr>
+        <p:spPr>
+          <a:xfrm>
+            <a:off x="9464040" y="2240280"/>
+            <a:ext cx="347472" cy="347472"/>
+          </a:xfrm>
+          <a:prstGeom prst="ellipse">
+            <a:avLst/>
+          </a:prstGeom>
+          <a:solidFill>
             <a:srgbClr val="F2545B"/>
           </a:solidFill>
           <a:ln/>
@@ -4079,97 +4046,450 @@
       </p:sp>
       <p:sp>
         <p:nvSpPr>
-          <p:cNvPr id="12" name="punto"/>
-          <p:cNvSpPr/>
-          <p:nvPr/>
-        </p:nvSpPr>
-        <p:spPr>
-          <a:xfrm>
-            <a:off x="8019288" y="1078992"/>
-            <a:ext cx="128016" cy="128016"/>
+          <p:cNvPr id="23" name="alumno"/>
+          <p:cNvSpPr/>
+          <p:nvPr/>
+        </p:nvSpPr>
+        <p:spPr>
+          <a:xfrm>
+            <a:off x="10012680" y="2240280"/>
+            <a:ext cx="347472" cy="347472"/>
           </a:xfrm>
           <a:prstGeom prst="ellipse">
             <a:avLst/>
           </a:prstGeom>
           <a:solidFill>
-            <a:srgbClr val="F5B841"/>
-          </a:solidFill>
-          <a:ln/>
-        </p:spPr>
-      </p:sp>
-      <p:sp>
-        <p:nvSpPr>
-          <p:cNvPr id="13" name="punto"/>
-          <p:cNvSpPr/>
-          <p:nvPr/>
-        </p:nvSpPr>
-        <p:spPr>
-          <a:xfrm>
-            <a:off x="8220456" y="1078992"/>
-            <a:ext cx="128016" cy="128016"/>
+            <a:srgbClr val="F2545B"/>
+          </a:solidFill>
+          <a:ln/>
+        </p:spPr>
+      </p:sp>
+      <p:sp>
+        <p:nvSpPr>
+          <p:cNvPr id="24" name="alumno"/>
+          <p:cNvSpPr/>
+          <p:nvPr/>
+        </p:nvSpPr>
+        <p:spPr>
+          <a:xfrm>
+            <a:off x="10561320" y="2240280"/>
+            <a:ext cx="347472" cy="347472"/>
           </a:xfrm>
           <a:prstGeom prst="ellipse">
             <a:avLst/>
           </a:prstGeom>
           <a:solidFill>
-            <a:srgbClr val="5BC27A"/>
-          </a:solidFill>
-          <a:ln/>
-        </p:spPr>
-      </p:sp>
-      <p:sp>
-        <p:nvSpPr>
-          <p:cNvPr id="14" name="url"/>
-          <p:cNvSpPr/>
-          <p:nvPr/>
-        </p:nvSpPr>
-        <p:spPr>
-          <a:xfrm>
-            <a:off x="8503920" y="1014984"/>
-            <a:ext cx="2971800" cy="256032"/>
-          </a:xfrm>
-          <a:prstGeom prst="roundRect">
-            <a:avLst>
-              <a:gd name="adj" fmla="val 50000"/>
-            </a:avLst>
-          </a:prstGeom>
-          <a:solidFill>
-            <a:srgbClr val="FFFFFF"/>
-          </a:solidFill>
-          <a:ln w="9525">
-            <a:solidFill>
-              <a:srgbClr val="D9D0F0"/>
-            </a:solidFill>
-            <a:prstDash val="solid"/>
-          </a:ln>
-        </p:spPr>
-      </p:sp>
-      <p:sp>
-        <p:nvSpPr>
-          <p:cNvPr id="15" name="Text 12"/>
-          <p:cNvSpPr txBox="1"/>
-          <p:nvPr/>
-        </p:nvSpPr>
-        <p:spPr>
-          <a:xfrm>
-            <a:off x="8641080" y="1014984"/>
-            <a:ext cx="2743200" cy="256032"/>
-          </a:xfrm>
-          <a:prstGeom prst="rect">
-            <a:avLst/>
-          </a:prstGeom>
-          <a:noFill/>
-          <a:ln/>
-        </p:spPr>
-        <p:txBody>
-          <a:bodyPr wrap="square" lIns="0" tIns="0" rIns="0" bIns="0" rtlCol="0" anchor="ctr"/>
+            <a:srgbClr val="F2545B"/>
+          </a:solidFill>
+          <a:ln/>
+        </p:spPr>
+      </p:sp>
+      <p:sp>
+        <p:nvSpPr>
+          <p:cNvPr id="25" name="alumno"/>
+          <p:cNvSpPr/>
+          <p:nvPr/>
+        </p:nvSpPr>
+        <p:spPr>
+          <a:xfrm>
+            <a:off x="11109960" y="2240280"/>
+            <a:ext cx="347472" cy="347472"/>
+          </a:xfrm>
+          <a:prstGeom prst="ellipse">
+            <a:avLst/>
+          </a:prstGeom>
+          <a:solidFill>
+            <a:srgbClr val="F2545B"/>
+          </a:solidFill>
+          <a:ln/>
+        </p:spPr>
+      </p:sp>
+      <p:sp>
+        <p:nvSpPr>
+          <p:cNvPr id="26" name="alumno"/>
+          <p:cNvSpPr/>
+          <p:nvPr/>
+        </p:nvSpPr>
+        <p:spPr>
+          <a:xfrm>
+            <a:off x="8366760" y="2788920"/>
+            <a:ext cx="347472" cy="347472"/>
+          </a:xfrm>
+          <a:prstGeom prst="ellipse">
+            <a:avLst/>
+          </a:prstGeom>
+          <a:solidFill>
+            <a:srgbClr val="3A2E66"/>
+          </a:solidFill>
+          <a:ln/>
+        </p:spPr>
+      </p:sp>
+      <p:sp>
+        <p:nvSpPr>
+          <p:cNvPr id="27" name="alumno"/>
+          <p:cNvSpPr/>
+          <p:nvPr/>
+        </p:nvSpPr>
+        <p:spPr>
+          <a:xfrm>
+            <a:off x="8915400" y="2788920"/>
+            <a:ext cx="347472" cy="347472"/>
+          </a:xfrm>
+          <a:prstGeom prst="ellipse">
+            <a:avLst/>
+          </a:prstGeom>
+          <a:solidFill>
+            <a:srgbClr val="3A2E66"/>
+          </a:solidFill>
+          <a:ln/>
+        </p:spPr>
+      </p:sp>
+      <p:sp>
+        <p:nvSpPr>
+          <p:cNvPr id="28" name="alumno"/>
+          <p:cNvSpPr/>
+          <p:nvPr/>
+        </p:nvSpPr>
+        <p:spPr>
+          <a:xfrm>
+            <a:off x="9464040" y="2788920"/>
+            <a:ext cx="347472" cy="347472"/>
+          </a:xfrm>
+          <a:prstGeom prst="ellipse">
+            <a:avLst/>
+          </a:prstGeom>
+          <a:solidFill>
+            <a:srgbClr val="F2545B"/>
+          </a:solidFill>
+          <a:ln/>
+        </p:spPr>
+      </p:sp>
+      <p:sp>
+        <p:nvSpPr>
+          <p:cNvPr id="29" name="alumno"/>
+          <p:cNvSpPr/>
+          <p:nvPr/>
+        </p:nvSpPr>
+        <p:spPr>
+          <a:xfrm>
+            <a:off x="10012680" y="2788920"/>
+            <a:ext cx="347472" cy="347472"/>
+          </a:xfrm>
+          <a:prstGeom prst="ellipse">
+            <a:avLst/>
+          </a:prstGeom>
+          <a:solidFill>
+            <a:srgbClr val="F2545B"/>
+          </a:solidFill>
+          <a:ln/>
+        </p:spPr>
+      </p:sp>
+      <p:sp>
+        <p:nvSpPr>
+          <p:cNvPr id="30" name="alumno"/>
+          <p:cNvSpPr/>
+          <p:nvPr/>
+        </p:nvSpPr>
+        <p:spPr>
+          <a:xfrm>
+            <a:off x="10561320" y="2788920"/>
+            <a:ext cx="347472" cy="347472"/>
+          </a:xfrm>
+          <a:prstGeom prst="ellipse">
+            <a:avLst/>
+          </a:prstGeom>
+          <a:solidFill>
+            <a:srgbClr val="F2545B"/>
+          </a:solidFill>
+          <a:ln/>
+        </p:spPr>
+      </p:sp>
+      <p:sp>
+        <p:nvSpPr>
+          <p:cNvPr id="31" name="alumno"/>
+          <p:cNvSpPr/>
+          <p:nvPr/>
+        </p:nvSpPr>
+        <p:spPr>
+          <a:xfrm>
+            <a:off x="11109960" y="2788920"/>
+            <a:ext cx="347472" cy="347472"/>
+          </a:xfrm>
+          <a:prstGeom prst="ellipse">
+            <a:avLst/>
+          </a:prstGeom>
+          <a:solidFill>
+            <a:srgbClr val="F2545B"/>
+          </a:solidFill>
+          <a:ln/>
+        </p:spPr>
+      </p:sp>
+      <p:sp>
+        <p:nvSpPr>
+          <p:cNvPr id="32" name="alumno"/>
+          <p:cNvSpPr/>
+          <p:nvPr/>
+        </p:nvSpPr>
+        <p:spPr>
+          <a:xfrm>
+            <a:off x="8366760" y="3337560"/>
+            <a:ext cx="347472" cy="347472"/>
+          </a:xfrm>
+          <a:prstGeom prst="ellipse">
+            <a:avLst/>
+          </a:prstGeom>
+          <a:solidFill>
+            <a:srgbClr val="3A2E66"/>
+          </a:solidFill>
+          <a:ln/>
+        </p:spPr>
+      </p:sp>
+      <p:sp>
+        <p:nvSpPr>
+          <p:cNvPr id="33" name="alumno"/>
+          <p:cNvSpPr/>
+          <p:nvPr/>
+        </p:nvSpPr>
+        <p:spPr>
+          <a:xfrm>
+            <a:off x="8915400" y="3337560"/>
+            <a:ext cx="347472" cy="347472"/>
+          </a:xfrm>
+          <a:prstGeom prst="ellipse">
+            <a:avLst/>
+          </a:prstGeom>
+          <a:solidFill>
+            <a:srgbClr val="3A2E66"/>
+          </a:solidFill>
+          <a:ln/>
+        </p:spPr>
+      </p:sp>
+      <p:sp>
+        <p:nvSpPr>
+          <p:cNvPr id="34" name="alumno"/>
+          <p:cNvSpPr/>
+          <p:nvPr/>
+        </p:nvSpPr>
+        <p:spPr>
+          <a:xfrm>
+            <a:off x="9464040" y="3337560"/>
+            <a:ext cx="347472" cy="347472"/>
+          </a:xfrm>
+          <a:prstGeom prst="ellipse">
+            <a:avLst/>
+          </a:prstGeom>
+          <a:solidFill>
+            <a:srgbClr val="F2545B"/>
+          </a:solidFill>
+          <a:ln/>
+        </p:spPr>
+      </p:sp>
+      <p:sp>
+        <p:nvSpPr>
+          <p:cNvPr id="35" name="alumno"/>
+          <p:cNvSpPr/>
+          <p:nvPr/>
+        </p:nvSpPr>
+        <p:spPr>
+          <a:xfrm>
+            <a:off x="10012680" y="3337560"/>
+            <a:ext cx="347472" cy="347472"/>
+          </a:xfrm>
+          <a:prstGeom prst="ellipse">
+            <a:avLst/>
+          </a:prstGeom>
+          <a:solidFill>
+            <a:srgbClr val="F2545B"/>
+          </a:solidFill>
+          <a:ln/>
+        </p:spPr>
+      </p:sp>
+      <p:sp>
+        <p:nvSpPr>
+          <p:cNvPr id="36" name="alumno"/>
+          <p:cNvSpPr/>
+          <p:nvPr/>
+        </p:nvSpPr>
+        <p:spPr>
+          <a:xfrm>
+            <a:off x="10561320" y="3337560"/>
+            <a:ext cx="347472" cy="347472"/>
+          </a:xfrm>
+          <a:prstGeom prst="ellipse">
+            <a:avLst/>
+          </a:prstGeom>
+          <a:solidFill>
+            <a:srgbClr val="F2545B"/>
+          </a:solidFill>
+          <a:ln/>
+        </p:spPr>
+      </p:sp>
+      <p:sp>
+        <p:nvSpPr>
+          <p:cNvPr id="37" name="alumno"/>
+          <p:cNvSpPr/>
+          <p:nvPr/>
+        </p:nvSpPr>
+        <p:spPr>
+          <a:xfrm>
+            <a:off x="11109960" y="3337560"/>
+            <a:ext cx="347472" cy="347472"/>
+          </a:xfrm>
+          <a:prstGeom prst="ellipse">
+            <a:avLst/>
+          </a:prstGeom>
+          <a:solidFill>
+            <a:srgbClr val="F2545B"/>
+          </a:solidFill>
+          <a:ln/>
+        </p:spPr>
+      </p:sp>
+      <p:sp>
+        <p:nvSpPr>
+          <p:cNvPr id="38" name="alumno"/>
+          <p:cNvSpPr/>
+          <p:nvPr/>
+        </p:nvSpPr>
+        <p:spPr>
+          <a:xfrm>
+            <a:off x="8366760" y="3886200"/>
+            <a:ext cx="347472" cy="347472"/>
+          </a:xfrm>
+          <a:prstGeom prst="ellipse">
+            <a:avLst/>
+          </a:prstGeom>
+          <a:solidFill>
+            <a:srgbClr val="3A2E66"/>
+          </a:solidFill>
+          <a:ln/>
+        </p:spPr>
+      </p:sp>
+      <p:sp>
+        <p:nvSpPr>
+          <p:cNvPr id="39" name="alumno"/>
+          <p:cNvSpPr/>
+          <p:nvPr/>
+        </p:nvSpPr>
+        <p:spPr>
+          <a:xfrm>
+            <a:off x="8915400" y="3886200"/>
+            <a:ext cx="347472" cy="347472"/>
+          </a:xfrm>
+          <a:prstGeom prst="ellipse">
+            <a:avLst/>
+          </a:prstGeom>
+          <a:solidFill>
+            <a:srgbClr val="3A2E66"/>
+          </a:solidFill>
+          <a:ln/>
+        </p:spPr>
+      </p:sp>
+      <p:sp>
+        <p:nvSpPr>
+          <p:cNvPr id="40" name="alumno"/>
+          <p:cNvSpPr/>
+          <p:nvPr/>
+        </p:nvSpPr>
+        <p:spPr>
+          <a:xfrm>
+            <a:off x="9464040" y="3886200"/>
+            <a:ext cx="347472" cy="347472"/>
+          </a:xfrm>
+          <a:prstGeom prst="ellipse">
+            <a:avLst/>
+          </a:prstGeom>
+          <a:solidFill>
+            <a:srgbClr val="3A2E66"/>
+          </a:solidFill>
+          <a:ln/>
+        </p:spPr>
+      </p:sp>
+      <p:sp>
+        <p:nvSpPr>
+          <p:cNvPr id="41" name="alumno"/>
+          <p:cNvSpPr/>
+          <p:nvPr/>
+        </p:nvSpPr>
+        <p:spPr>
+          <a:xfrm>
+            <a:off x="10012680" y="3886200"/>
+            <a:ext cx="347472" cy="347472"/>
+          </a:xfrm>
+          <a:prstGeom prst="ellipse">
+            <a:avLst/>
+          </a:prstGeom>
+          <a:solidFill>
+            <a:srgbClr val="3A2E66"/>
+          </a:solidFill>
+          <a:ln/>
+        </p:spPr>
+      </p:sp>
+      <p:sp>
+        <p:nvSpPr>
+          <p:cNvPr id="42" name="alumno"/>
+          <p:cNvSpPr/>
+          <p:nvPr/>
+        </p:nvSpPr>
+        <p:spPr>
+          <a:xfrm>
+            <a:off x="10561320" y="3886200"/>
+            <a:ext cx="347472" cy="347472"/>
+          </a:xfrm>
+          <a:prstGeom prst="ellipse">
+            <a:avLst/>
+          </a:prstGeom>
+          <a:solidFill>
+            <a:srgbClr val="3A2E66"/>
+          </a:solidFill>
+          <a:ln/>
+        </p:spPr>
+      </p:sp>
+      <p:sp>
+        <p:nvSpPr>
+          <p:cNvPr id="43" name="alumno"/>
+          <p:cNvSpPr/>
+          <p:nvPr/>
+        </p:nvSpPr>
+        <p:spPr>
+          <a:xfrm>
+            <a:off x="11109960" y="3886200"/>
+            <a:ext cx="347472" cy="347472"/>
+          </a:xfrm>
+          <a:prstGeom prst="ellipse">
+            <a:avLst/>
+          </a:prstGeom>
+          <a:solidFill>
+            <a:srgbClr val="3A2E66"/>
+          </a:solidFill>
+          <a:ln/>
+        </p:spPr>
+      </p:sp>
+      <p:sp>
+        <p:nvSpPr>
+          <p:cNvPr id="44" name="Text 41"/>
+          <p:cNvSpPr txBox="1"/>
+          <p:nvPr/>
+        </p:nvSpPr>
+        <p:spPr>
+          <a:xfrm>
+            <a:off x="8366760" y="4526280"/>
+            <a:ext cx="3291840" cy="365760"/>
+          </a:xfrm>
+          <a:prstGeom prst="rect">
+            <a:avLst/>
+          </a:prstGeom>
+          <a:noFill/>
+          <a:ln/>
+        </p:spPr>
+        <p:txBody>
+          <a:bodyPr wrap="square" lIns="0" tIns="0" rIns="0" bIns="0" rtlCol="0" anchor="t"/>
           <a:lstStyle/>
           <a:p>
             <a:pPr indent="0" marL="0">
               <a:buNone/>
             </a:pPr>
             <a:r>
-              <a:rPr lang="en-US" sz="1000" dirty="0">
+              <a:rPr lang="en-US" sz="1200" i="1" dirty="0">
                 <a:solidFill>
                   <a:srgbClr val="7A7391"/>
                 </a:solidFill>
@@ -4177,374 +4497,9 @@
                 <a:ea typeface="Calibri" pitchFamily="34" charset="-122"/>
                 <a:cs typeface="Calibri" pitchFamily="34" charset="-120"/>
               </a:rPr>
-              <a:t>sysacad · inscripción a cursado</a:t>
-            </a:r>
-            <a:endParaRPr lang="en-US" sz="1000" dirty="0"/>
-          </a:p>
-        </p:txBody>
-      </p:sp>
-      <p:sp>
-        <p:nvSpPr>
-          <p:cNvPr id="16" name="Text 13"/>
-          <p:cNvSpPr txBox="1"/>
-          <p:nvPr/>
-        </p:nvSpPr>
-        <p:spPr>
-          <a:xfrm>
-            <a:off x="7955280" y="1554480"/>
-            <a:ext cx="2011680" cy="914400"/>
-          </a:xfrm>
-          <a:prstGeom prst="rect">
-            <a:avLst/>
-          </a:prstGeom>
-          <a:noFill/>
-          <a:ln/>
-        </p:spPr>
-        <p:txBody>
-          <a:bodyPr wrap="square" lIns="0" tIns="0" rIns="0" bIns="0" rtlCol="0" anchor="ctr"/>
-          <a:lstStyle/>
-          <a:p>
-            <a:pPr indent="0" marL="0">
-              <a:buNone/>
-            </a:pPr>
-            <a:r>
-              <a:rPr lang="en-US" sz="6000" b="1" dirty="0">
-                <a:solidFill>
-                  <a:srgbClr val="F2545B"/>
-                </a:solidFill>
-                <a:latin typeface="Cambria" pitchFamily="34" charset="0"/>
-                <a:ea typeface="Cambria" pitchFamily="34" charset="-122"/>
-                <a:cs typeface="Cambria" pitchFamily="34" charset="-120"/>
-              </a:rPr>
-              <a:t>503</a:t>
-            </a:r>
-            <a:endParaRPr lang="en-US" sz="6000" dirty="0"/>
-          </a:p>
-        </p:txBody>
-      </p:sp>
-      <p:sp>
-        <p:nvSpPr>
-          <p:cNvPr id="17" name="Text 14"/>
-          <p:cNvSpPr txBox="1"/>
-          <p:nvPr/>
-        </p:nvSpPr>
-        <p:spPr>
-          <a:xfrm>
-            <a:off x="7955280" y="2514600"/>
-            <a:ext cx="3383280" cy="731520"/>
-          </a:xfrm>
-          <a:prstGeom prst="rect">
-            <a:avLst/>
-          </a:prstGeom>
-          <a:noFill/>
-          <a:ln/>
-        </p:spPr>
-        <p:txBody>
-          <a:bodyPr wrap="square" lIns="0" tIns="0" rIns="0" bIns="0" rtlCol="0" anchor="t"/>
-          <a:lstStyle/>
-          <a:p>
-            <a:pPr indent="0" marL="0">
-              <a:buNone/>
-            </a:pPr>
-            <a:r>
-              <a:rPr lang="en-US" sz="1500" b="1" dirty="0">
-                <a:solidFill>
-                  <a:srgbClr val="1E1433"/>
-                </a:solidFill>
-                <a:latin typeface="Calibri" pitchFamily="34" charset="0"/>
-                <a:ea typeface="Calibri" pitchFamily="34" charset="-122"/>
-                <a:cs typeface="Calibri" pitchFamily="34" charset="-120"/>
-              </a:rPr>
-              <a:t>Servicio no disponible</a:t>
-            </a:r>
-            <a:endParaRPr lang="en-US" sz="1500" dirty="0"/>
-          </a:p>
-          <a:p>
-            <a:pPr indent="0" marL="0">
-              <a:buNone/>
-            </a:pPr>
-            <a:r>
-              <a:rPr lang="en-US" sz="1200" dirty="0">
-                <a:solidFill>
-                  <a:srgbClr val="4A4560"/>
-                </a:solidFill>
-                <a:latin typeface="Calibri" pitchFamily="34" charset="0"/>
-                <a:ea typeface="Calibri" pitchFamily="34" charset="-122"/>
-                <a:cs typeface="Calibri" pitchFamily="34" charset="-120"/>
-              </a:rPr>
-              <a:t>Demasiados usuarios conectados. Intente más tarde.</a:t>
-            </a:r>
-            <a:endParaRPr lang="en-US" sz="1500" dirty="0"/>
-          </a:p>
-        </p:txBody>
-      </p:sp>
-      <p:sp>
-        <p:nvSpPr>
-          <p:cNvPr id="18" name="spinner"/>
-          <p:cNvSpPr/>
-          <p:nvPr/>
-        </p:nvSpPr>
-        <p:spPr>
-          <a:xfrm>
-            <a:off x="11192256" y="1956816"/>
-            <a:ext cx="109728" cy="109728"/>
-          </a:xfrm>
-          <a:prstGeom prst="ellipse">
-            <a:avLst/>
-          </a:prstGeom>
-          <a:solidFill>
-            <a:srgbClr val="3B1F78">
-              <a:alpha val="90000"/>
-            </a:srgbClr>
-          </a:solidFill>
-          <a:ln/>
-        </p:spPr>
-      </p:sp>
-      <p:sp>
-        <p:nvSpPr>
-          <p:cNvPr id="19" name="spinner"/>
-          <p:cNvSpPr/>
-          <p:nvPr/>
-        </p:nvSpPr>
-        <p:spPr>
-          <a:xfrm>
-            <a:off x="11111910" y="2150790"/>
-            <a:ext cx="109728" cy="109728"/>
-          </a:xfrm>
-          <a:prstGeom prst="ellipse">
-            <a:avLst/>
-          </a:prstGeom>
-          <a:solidFill>
-            <a:srgbClr val="3B1F78">
-              <a:alpha val="79000"/>
-            </a:srgbClr>
-          </a:solidFill>
-          <a:ln/>
-        </p:spPr>
-      </p:sp>
-      <p:sp>
-        <p:nvSpPr>
-          <p:cNvPr id="20" name="spinner"/>
-          <p:cNvSpPr/>
-          <p:nvPr/>
-        </p:nvSpPr>
-        <p:spPr>
-          <a:xfrm>
-            <a:off x="10917936" y="2231136"/>
-            <a:ext cx="109728" cy="109728"/>
-          </a:xfrm>
-          <a:prstGeom prst="ellipse">
-            <a:avLst/>
-          </a:prstGeom>
-          <a:solidFill>
-            <a:srgbClr val="3B1F78">
-              <a:alpha val="68000"/>
-            </a:srgbClr>
-          </a:solidFill>
-          <a:ln/>
-        </p:spPr>
-      </p:sp>
-      <p:sp>
-        <p:nvSpPr>
-          <p:cNvPr id="21" name="spinner"/>
-          <p:cNvSpPr/>
-          <p:nvPr/>
-        </p:nvSpPr>
-        <p:spPr>
-          <a:xfrm>
-            <a:off x="10723962" y="2150790"/>
-            <a:ext cx="109728" cy="109728"/>
-          </a:xfrm>
-          <a:prstGeom prst="ellipse">
-            <a:avLst/>
-          </a:prstGeom>
-          <a:solidFill>
-            <a:srgbClr val="3B1F78">
-              <a:alpha val="57000"/>
-            </a:srgbClr>
-          </a:solidFill>
-          <a:ln/>
-        </p:spPr>
-      </p:sp>
-      <p:sp>
-        <p:nvSpPr>
-          <p:cNvPr id="22" name="spinner"/>
-          <p:cNvSpPr/>
-          <p:nvPr/>
-        </p:nvSpPr>
-        <p:spPr>
-          <a:xfrm>
-            <a:off x="10643616" y="1956816"/>
-            <a:ext cx="109728" cy="109728"/>
-          </a:xfrm>
-          <a:prstGeom prst="ellipse">
-            <a:avLst/>
-          </a:prstGeom>
-          <a:solidFill>
-            <a:srgbClr val="3B1F78">
-              <a:alpha val="46000"/>
-            </a:srgbClr>
-          </a:solidFill>
-          <a:ln/>
-        </p:spPr>
-      </p:sp>
-      <p:sp>
-        <p:nvSpPr>
-          <p:cNvPr id="23" name="spinner"/>
-          <p:cNvSpPr/>
-          <p:nvPr/>
-        </p:nvSpPr>
-        <p:spPr>
-          <a:xfrm>
-            <a:off x="10723962" y="1762842"/>
-            <a:ext cx="109728" cy="109728"/>
-          </a:xfrm>
-          <a:prstGeom prst="ellipse">
-            <a:avLst/>
-          </a:prstGeom>
-          <a:solidFill>
-            <a:srgbClr val="3B1F78">
-              <a:alpha val="35000"/>
-            </a:srgbClr>
-          </a:solidFill>
-          <a:ln/>
-        </p:spPr>
-      </p:sp>
-      <p:sp>
-        <p:nvSpPr>
-          <p:cNvPr id="24" name="spinner"/>
-          <p:cNvSpPr/>
-          <p:nvPr/>
-        </p:nvSpPr>
-        <p:spPr>
-          <a:xfrm>
-            <a:off x="10917936" y="1682496"/>
-            <a:ext cx="109728" cy="109728"/>
-          </a:xfrm>
-          <a:prstGeom prst="ellipse">
-            <a:avLst/>
-          </a:prstGeom>
-          <a:solidFill>
-            <a:srgbClr val="3B1F78">
-              <a:alpha val="24000"/>
-            </a:srgbClr>
-          </a:solidFill>
-          <a:ln/>
-        </p:spPr>
-      </p:sp>
-      <p:sp>
-        <p:nvSpPr>
-          <p:cNvPr id="25" name="spinner"/>
-          <p:cNvSpPr/>
-          <p:nvPr/>
-        </p:nvSpPr>
-        <p:spPr>
-          <a:xfrm>
-            <a:off x="11111910" y="1762842"/>
-            <a:ext cx="109728" cy="109728"/>
-          </a:xfrm>
-          <a:prstGeom prst="ellipse">
-            <a:avLst/>
-          </a:prstGeom>
-          <a:solidFill>
-            <a:srgbClr val="3B1F78">
-              <a:alpha val="13000"/>
-            </a:srgbClr>
-          </a:solidFill>
-          <a:ln/>
-        </p:spPr>
-      </p:sp>
-      <p:graphicFrame>
-        <p:nvGraphicFramePr>
-          <p:cNvPr id="26" name="Chart 0" descr=""/>
-          <p:cNvGraphicFramePr/>
-          <p:nvPr/>
-        </p:nvGraphicFramePr>
-        <p:xfrm>
-          <a:off x="7818120" y="3337560"/>
-          <a:ext cx="3657600" cy="1554480"/>
-        </p:xfrm>
-        <a:graphic xmlns:a="http://schemas.openxmlformats.org/drawingml/2006/main">
-          <a:graphicData uri="http://schemas.openxmlformats.org/drawingml/2006/chart">
-            <c:chart xmlns:c="http://schemas.openxmlformats.org/drawingml/2006/chart" r:id="rId1"/>
-          </a:graphicData>
-        </a:graphic>
-      </p:graphicFrame>
-      <p:sp>
-        <p:nvSpPr>
-          <p:cNvPr id="27" name="Text 23"/>
-          <p:cNvSpPr txBox="1"/>
-          <p:nvPr/>
-        </p:nvSpPr>
-        <p:spPr>
-          <a:xfrm>
-            <a:off x="7955280" y="4873752"/>
-            <a:ext cx="3383280" cy="274320"/>
-          </a:xfrm>
-          <a:prstGeom prst="rect">
-            <a:avLst/>
-          </a:prstGeom>
-          <a:noFill/>
-          <a:ln/>
-        </p:spPr>
-        <p:txBody>
-          <a:bodyPr wrap="square" lIns="0" tIns="0" rIns="0" bIns="0" rtlCol="0" anchor="t"/>
-          <a:lstStyle/>
-          <a:p>
-            <a:pPr indent="0" marL="0">
-              <a:buNone/>
-            </a:pPr>
-            <a:r>
-              <a:rPr lang="en-US" sz="1000" i="1" dirty="0">
-                <a:solidFill>
-                  <a:srgbClr val="7A7391"/>
-                </a:solidFill>
-                <a:latin typeface="Calibri" pitchFamily="34" charset="0"/>
-                <a:ea typeface="Calibri" pitchFamily="34" charset="-122"/>
-                <a:cs typeface="Calibri" pitchFamily="34" charset="-120"/>
-              </a:rPr>
-              <a:t>pedidos por minuto · día de inscripción</a:t>
-            </a:r>
-            <a:endParaRPr lang="en-US" sz="1000" dirty="0"/>
-          </a:p>
-        </p:txBody>
-      </p:sp>
-      <p:sp>
-        <p:nvSpPr>
-          <p:cNvPr id="28" name="Text 24"/>
-          <p:cNvSpPr txBox="1"/>
-          <p:nvPr/>
-        </p:nvSpPr>
-        <p:spPr>
-          <a:xfrm>
-            <a:off x="7635240" y="5367528"/>
-            <a:ext cx="4023360" cy="274320"/>
-          </a:xfrm>
-          <a:prstGeom prst="rect">
-            <a:avLst/>
-          </a:prstGeom>
-          <a:noFill/>
-          <a:ln/>
-        </p:spPr>
-        <p:txBody>
-          <a:bodyPr wrap="square" lIns="0" tIns="0" rIns="0" bIns="0" rtlCol="0" anchor="t"/>
-          <a:lstStyle/>
-          <a:p>
-            <a:pPr algn="r" indent="0" marL="0">
-              <a:buNone/>
-            </a:pPr>
-            <a:r>
-              <a:rPr lang="en-US" sz="1000" i="1" dirty="0">
-                <a:solidFill>
-                  <a:srgbClr val="7A7391"/>
-                </a:solidFill>
-                <a:latin typeface="Calibri" pitchFamily="34" charset="0"/>
-                <a:ea typeface="Calibri" pitchFamily="34" charset="-122"/>
-                <a:cs typeface="Calibri" pitchFamily="34" charset="-120"/>
-              </a:rPr>
-              <a:t>Recreación ilustrativa, no una captura real</a:t>
-            </a:r>
-            <a:endParaRPr lang="en-US" sz="1000" dirty="0"/>
+              <a:t>El día de inscripción, todos a la vez</a:t>
+            </a:r>
+            <a:endParaRPr lang="en-US" sz="1200" dirty="0"/>
           </a:p>
         </p:txBody>
       </p:sp>
@@ -10350,15 +10305,788 @@
           </a:p>
         </p:txBody>
       </p:sp>
+      <p:sp>
+        <p:nvSpPr>
+          <p:cNvPr id="5" name="navegador"/>
+          <p:cNvSpPr/>
+          <p:nvPr/>
+        </p:nvSpPr>
+        <p:spPr>
+          <a:xfrm>
+            <a:off x="548640" y="1600200"/>
+            <a:ext cx="4572000" cy="2743200"/>
+          </a:xfrm>
+          <a:prstGeom prst="roundRect">
+            <a:avLst>
+              <a:gd name="adj" fmla="val 4000"/>
+            </a:avLst>
+          </a:prstGeom>
+          <a:solidFill>
+            <a:srgbClr val="FFFFFF"/>
+          </a:solidFill>
+          <a:ln w="12700">
+            <a:solidFill>
+              <a:srgbClr val="D9D0F0"/>
+            </a:solidFill>
+            <a:prstDash val="solid"/>
+          </a:ln>
+          <a:effectLst>
+            <a:outerShdw sx="100000" sy="100000" kx="0" ky="0" algn="bl" rotWithShape="0" blurRad="127000" dist="38100" dir="5400000">
+              <a:srgbClr val="3B1F78">
+                <a:alpha val="18000"/>
+              </a:srgbClr>
+            </a:outerShdw>
+          </a:effectLst>
+        </p:spPr>
+      </p:sp>
+      <p:sp>
+        <p:nvSpPr>
+          <p:cNvPr id="6" name="barra"/>
+          <p:cNvSpPr/>
+          <p:nvPr/>
+        </p:nvSpPr>
+        <p:spPr>
+          <a:xfrm>
+            <a:off x="548640" y="1600200"/>
+            <a:ext cx="4572000" cy="457200"/>
+          </a:xfrm>
+          <a:prstGeom prst="roundRect">
+            <a:avLst>
+              <a:gd name="adj" fmla="val 24000"/>
+            </a:avLst>
+          </a:prstGeom>
+          <a:solidFill>
+            <a:srgbClr val="F1EDFA"/>
+          </a:solidFill>
+          <a:ln/>
+        </p:spPr>
+      </p:sp>
+      <p:sp>
+        <p:nvSpPr>
+          <p:cNvPr id="7" name="barra-base"/>
+          <p:cNvSpPr/>
+          <p:nvPr/>
+        </p:nvSpPr>
+        <p:spPr>
+          <a:xfrm>
+            <a:off x="548640" y="1874520"/>
+            <a:ext cx="4572000" cy="182880"/>
+          </a:xfrm>
+          <a:prstGeom prst="rect">
+            <a:avLst/>
+          </a:prstGeom>
+          <a:solidFill>
+            <a:srgbClr val="F1EDFA"/>
+          </a:solidFill>
+          <a:ln/>
+        </p:spPr>
+      </p:sp>
+      <p:sp>
+        <p:nvSpPr>
+          <p:cNvPr id="8" name="punto"/>
+          <p:cNvSpPr/>
+          <p:nvPr/>
+        </p:nvSpPr>
+        <p:spPr>
+          <a:xfrm>
+            <a:off x="731520" y="1764792"/>
+            <a:ext cx="128016" cy="128016"/>
+          </a:xfrm>
+          <a:prstGeom prst="ellipse">
+            <a:avLst/>
+          </a:prstGeom>
+          <a:solidFill>
+            <a:srgbClr val="F2545B"/>
+          </a:solidFill>
+          <a:ln/>
+        </p:spPr>
+      </p:sp>
+      <p:sp>
+        <p:nvSpPr>
+          <p:cNvPr id="9" name="punto"/>
+          <p:cNvSpPr/>
+          <p:nvPr/>
+        </p:nvSpPr>
+        <p:spPr>
+          <a:xfrm>
+            <a:off x="932688" y="1764792"/>
+            <a:ext cx="128016" cy="128016"/>
+          </a:xfrm>
+          <a:prstGeom prst="ellipse">
+            <a:avLst/>
+          </a:prstGeom>
+          <a:solidFill>
+            <a:srgbClr val="F5B841"/>
+          </a:solidFill>
+          <a:ln/>
+        </p:spPr>
+      </p:sp>
+      <p:sp>
+        <p:nvSpPr>
+          <p:cNvPr id="10" name="punto"/>
+          <p:cNvSpPr/>
+          <p:nvPr/>
+        </p:nvSpPr>
+        <p:spPr>
+          <a:xfrm>
+            <a:off x="1133856" y="1764792"/>
+            <a:ext cx="128016" cy="128016"/>
+          </a:xfrm>
+          <a:prstGeom prst="ellipse">
+            <a:avLst/>
+          </a:prstGeom>
+          <a:solidFill>
+            <a:srgbClr val="5BC27A"/>
+          </a:solidFill>
+          <a:ln/>
+        </p:spPr>
+      </p:sp>
+      <p:sp>
+        <p:nvSpPr>
+          <p:cNvPr id="11" name="url"/>
+          <p:cNvSpPr/>
+          <p:nvPr/>
+        </p:nvSpPr>
+        <p:spPr>
+          <a:xfrm>
+            <a:off x="1417320" y="1700784"/>
+            <a:ext cx="3520440" cy="256032"/>
+          </a:xfrm>
+          <a:prstGeom prst="roundRect">
+            <a:avLst>
+              <a:gd name="adj" fmla="val 50000"/>
+            </a:avLst>
+          </a:prstGeom>
+          <a:solidFill>
+            <a:srgbClr val="FFFFFF"/>
+          </a:solidFill>
+          <a:ln w="9525">
+            <a:solidFill>
+              <a:srgbClr val="D9D0F0"/>
+            </a:solidFill>
+            <a:prstDash val="solid"/>
+          </a:ln>
+        </p:spPr>
+      </p:sp>
+      <p:sp>
+        <p:nvSpPr>
+          <p:cNvPr id="12" name="Text 9"/>
+          <p:cNvSpPr txBox="1"/>
+          <p:nvPr/>
+        </p:nvSpPr>
+        <p:spPr>
+          <a:xfrm>
+            <a:off x="1554480" y="1700784"/>
+            <a:ext cx="3291840" cy="256032"/>
+          </a:xfrm>
+          <a:prstGeom prst="rect">
+            <a:avLst/>
+          </a:prstGeom>
+          <a:noFill/>
+          <a:ln/>
+        </p:spPr>
+        <p:txBody>
+          <a:bodyPr wrap="square" lIns="0" tIns="0" rIns="0" bIns="0" rtlCol="0" anchor="ctr"/>
+          <a:lstStyle/>
+          <a:p>
+            <a:pPr indent="0" marL="0">
+              <a:buNone/>
+            </a:pPr>
+            <a:r>
+              <a:rPr lang="en-US" sz="1000" dirty="0">
+                <a:solidFill>
+                  <a:srgbClr val="7A7391"/>
+                </a:solidFill>
+                <a:latin typeface="Calibri" pitchFamily="34" charset="0"/>
+                <a:ea typeface="Calibri" pitchFamily="34" charset="-122"/>
+                <a:cs typeface="Calibri" pitchFamily="34" charset="-120"/>
+              </a:rPr>
+              <a:t>sysacad · inscripción a cursado</a:t>
+            </a:r>
+            <a:endParaRPr lang="en-US" sz="1000" dirty="0"/>
+          </a:p>
+        </p:txBody>
+      </p:sp>
+      <p:sp>
+        <p:nvSpPr>
+          <p:cNvPr id="13" name="Text 10"/>
+          <p:cNvSpPr txBox="1"/>
+          <p:nvPr/>
+        </p:nvSpPr>
+        <p:spPr>
+          <a:xfrm>
+            <a:off x="914400" y="2286000"/>
+            <a:ext cx="2194560" cy="960120"/>
+          </a:xfrm>
+          <a:prstGeom prst="rect">
+            <a:avLst/>
+          </a:prstGeom>
+          <a:noFill/>
+          <a:ln/>
+        </p:spPr>
+        <p:txBody>
+          <a:bodyPr wrap="square" lIns="0" tIns="0" rIns="0" bIns="0" rtlCol="0" anchor="ctr"/>
+          <a:lstStyle/>
+          <a:p>
+            <a:pPr indent="0" marL="0">
+              <a:buNone/>
+            </a:pPr>
+            <a:r>
+              <a:rPr lang="en-US" sz="6400" b="1" dirty="0">
+                <a:solidFill>
+                  <a:srgbClr val="F2545B"/>
+                </a:solidFill>
+                <a:latin typeface="Cambria" pitchFamily="34" charset="0"/>
+                <a:ea typeface="Cambria" pitchFamily="34" charset="-122"/>
+                <a:cs typeface="Cambria" pitchFamily="34" charset="-120"/>
+              </a:rPr>
+              <a:t>503</a:t>
+            </a:r>
+            <a:endParaRPr lang="en-US" sz="6400" dirty="0"/>
+          </a:p>
+        </p:txBody>
+      </p:sp>
+      <p:sp>
+        <p:nvSpPr>
+          <p:cNvPr id="14" name="Text 11"/>
+          <p:cNvSpPr txBox="1"/>
+          <p:nvPr/>
+        </p:nvSpPr>
+        <p:spPr>
+          <a:xfrm>
+            <a:off x="914400" y="3383280"/>
+            <a:ext cx="3840480" cy="731520"/>
+          </a:xfrm>
+          <a:prstGeom prst="rect">
+            <a:avLst/>
+          </a:prstGeom>
+          <a:noFill/>
+          <a:ln/>
+        </p:spPr>
+        <p:txBody>
+          <a:bodyPr wrap="square" lIns="0" tIns="0" rIns="0" bIns="0" rtlCol="0" anchor="t"/>
+          <a:lstStyle/>
+          <a:p>
+            <a:pPr indent="0" marL="0">
+              <a:buNone/>
+            </a:pPr>
+            <a:r>
+              <a:rPr lang="en-US" sz="1700" b="1" dirty="0">
+                <a:solidFill>
+                  <a:srgbClr val="1E1433"/>
+                </a:solidFill>
+                <a:latin typeface="Calibri" pitchFamily="34" charset="0"/>
+                <a:ea typeface="Calibri" pitchFamily="34" charset="-122"/>
+                <a:cs typeface="Calibri" pitchFamily="34" charset="-120"/>
+              </a:rPr>
+              <a:t>Servicio no disponible</a:t>
+            </a:r>
+            <a:endParaRPr lang="en-US" sz="1700" dirty="0"/>
+          </a:p>
+          <a:p>
+            <a:pPr indent="0" marL="0">
+              <a:buNone/>
+            </a:pPr>
+            <a:r>
+              <a:rPr lang="en-US" sz="1300" dirty="0">
+                <a:solidFill>
+                  <a:srgbClr val="4A4560"/>
+                </a:solidFill>
+                <a:latin typeface="Calibri" pitchFamily="34" charset="0"/>
+                <a:ea typeface="Calibri" pitchFamily="34" charset="-122"/>
+                <a:cs typeface="Calibri" pitchFamily="34" charset="-120"/>
+              </a:rPr>
+              <a:t>Demasiados usuarios conectados. Intente más tarde.</a:t>
+            </a:r>
+            <a:endParaRPr lang="en-US" sz="1700" dirty="0"/>
+          </a:p>
+        </p:txBody>
+      </p:sp>
+      <p:sp>
+        <p:nvSpPr>
+          <p:cNvPr id="15" name="spinner"/>
+          <p:cNvSpPr/>
+          <p:nvPr/>
+        </p:nvSpPr>
+        <p:spPr>
+          <a:xfrm>
+            <a:off x="4530852" y="2702052"/>
+            <a:ext cx="118872" cy="118872"/>
+          </a:xfrm>
+          <a:prstGeom prst="ellipse">
+            <a:avLst/>
+          </a:prstGeom>
+          <a:solidFill>
+            <a:srgbClr val="3B1F78">
+              <a:alpha val="90000"/>
+            </a:srgbClr>
+          </a:solidFill>
+          <a:ln/>
+        </p:spPr>
+      </p:sp>
+      <p:sp>
+        <p:nvSpPr>
+          <p:cNvPr id="16" name="spinner"/>
+          <p:cNvSpPr/>
+          <p:nvPr/>
+        </p:nvSpPr>
+        <p:spPr>
+          <a:xfrm>
+            <a:off x="4445149" y="2908957"/>
+            <a:ext cx="118872" cy="118872"/>
+          </a:xfrm>
+          <a:prstGeom prst="ellipse">
+            <a:avLst/>
+          </a:prstGeom>
+          <a:solidFill>
+            <a:srgbClr val="3B1F78">
+              <a:alpha val="79000"/>
+            </a:srgbClr>
+          </a:solidFill>
+          <a:ln/>
+        </p:spPr>
+      </p:sp>
+      <p:sp>
+        <p:nvSpPr>
+          <p:cNvPr id="17" name="spinner"/>
+          <p:cNvSpPr/>
+          <p:nvPr/>
+        </p:nvSpPr>
+        <p:spPr>
+          <a:xfrm>
+            <a:off x="4238244" y="2994660"/>
+            <a:ext cx="118872" cy="118872"/>
+          </a:xfrm>
+          <a:prstGeom prst="ellipse">
+            <a:avLst/>
+          </a:prstGeom>
+          <a:solidFill>
+            <a:srgbClr val="3B1F78">
+              <a:alpha val="68000"/>
+            </a:srgbClr>
+          </a:solidFill>
+          <a:ln/>
+        </p:spPr>
+      </p:sp>
+      <p:sp>
+        <p:nvSpPr>
+          <p:cNvPr id="18" name="spinner"/>
+          <p:cNvSpPr/>
+          <p:nvPr/>
+        </p:nvSpPr>
+        <p:spPr>
+          <a:xfrm>
+            <a:off x="4031339" y="2908957"/>
+            <a:ext cx="118872" cy="118872"/>
+          </a:xfrm>
+          <a:prstGeom prst="ellipse">
+            <a:avLst/>
+          </a:prstGeom>
+          <a:solidFill>
+            <a:srgbClr val="3B1F78">
+              <a:alpha val="57000"/>
+            </a:srgbClr>
+          </a:solidFill>
+          <a:ln/>
+        </p:spPr>
+      </p:sp>
+      <p:sp>
+        <p:nvSpPr>
+          <p:cNvPr id="19" name="spinner"/>
+          <p:cNvSpPr/>
+          <p:nvPr/>
+        </p:nvSpPr>
+        <p:spPr>
+          <a:xfrm>
+            <a:off x="3945636" y="2702052"/>
+            <a:ext cx="118872" cy="118872"/>
+          </a:xfrm>
+          <a:prstGeom prst="ellipse">
+            <a:avLst/>
+          </a:prstGeom>
+          <a:solidFill>
+            <a:srgbClr val="3B1F78">
+              <a:alpha val="46000"/>
+            </a:srgbClr>
+          </a:solidFill>
+          <a:ln/>
+        </p:spPr>
+      </p:sp>
+      <p:sp>
+        <p:nvSpPr>
+          <p:cNvPr id="20" name="spinner"/>
+          <p:cNvSpPr/>
+          <p:nvPr/>
+        </p:nvSpPr>
+        <p:spPr>
+          <a:xfrm>
+            <a:off x="4031339" y="2495147"/>
+            <a:ext cx="118872" cy="118872"/>
+          </a:xfrm>
+          <a:prstGeom prst="ellipse">
+            <a:avLst/>
+          </a:prstGeom>
+          <a:solidFill>
+            <a:srgbClr val="3B1F78">
+              <a:alpha val="35000"/>
+            </a:srgbClr>
+          </a:solidFill>
+          <a:ln/>
+        </p:spPr>
+      </p:sp>
+      <p:sp>
+        <p:nvSpPr>
+          <p:cNvPr id="21" name="spinner"/>
+          <p:cNvSpPr/>
+          <p:nvPr/>
+        </p:nvSpPr>
+        <p:spPr>
+          <a:xfrm>
+            <a:off x="4238244" y="2409444"/>
+            <a:ext cx="118872" cy="118872"/>
+          </a:xfrm>
+          <a:prstGeom prst="ellipse">
+            <a:avLst/>
+          </a:prstGeom>
+          <a:solidFill>
+            <a:srgbClr val="3B1F78">
+              <a:alpha val="24000"/>
+            </a:srgbClr>
+          </a:solidFill>
+          <a:ln/>
+        </p:spPr>
+      </p:sp>
+      <p:sp>
+        <p:nvSpPr>
+          <p:cNvPr id="22" name="spinner"/>
+          <p:cNvSpPr/>
+          <p:nvPr/>
+        </p:nvSpPr>
+        <p:spPr>
+          <a:xfrm>
+            <a:off x="4445149" y="2495147"/>
+            <a:ext cx="118872" cy="118872"/>
+          </a:xfrm>
+          <a:prstGeom prst="ellipse">
+            <a:avLst/>
+          </a:prstGeom>
+          <a:solidFill>
+            <a:srgbClr val="3B1F78">
+              <a:alpha val="13000"/>
+            </a:srgbClr>
+          </a:solidFill>
+          <a:ln/>
+        </p:spPr>
+      </p:sp>
+      <p:sp>
+        <p:nvSpPr>
+          <p:cNvPr id="23" name="Text 20"/>
+          <p:cNvSpPr txBox="1"/>
+          <p:nvPr/>
+        </p:nvSpPr>
+        <p:spPr>
+          <a:xfrm>
+            <a:off x="548640" y="4416552"/>
+            <a:ext cx="4572000" cy="228600"/>
+          </a:xfrm>
+          <a:prstGeom prst="rect">
+            <a:avLst/>
+          </a:prstGeom>
+          <a:noFill/>
+          <a:ln/>
+        </p:spPr>
+        <p:txBody>
+          <a:bodyPr wrap="square" lIns="0" tIns="0" rIns="0" bIns="0" rtlCol="0" anchor="t"/>
+          <a:lstStyle/>
+          <a:p>
+            <a:pPr indent="0" marL="0">
+              <a:buNone/>
+            </a:pPr>
+            <a:r>
+              <a:rPr lang="en-US" sz="1000" i="1" dirty="0">
+                <a:solidFill>
+                  <a:srgbClr val="7A7391"/>
+                </a:solidFill>
+                <a:latin typeface="Calibri" pitchFamily="34" charset="0"/>
+                <a:ea typeface="Calibri" pitchFamily="34" charset="-122"/>
+                <a:cs typeface="Calibri" pitchFamily="34" charset="-120"/>
+              </a:rPr>
+              <a:t>Recreación ilustrativa, no una captura real</a:t>
+            </a:r>
+            <a:endParaRPr lang="en-US" sz="1000" dirty="0"/>
+          </a:p>
+        </p:txBody>
+      </p:sp>
+      <p:sp>
+        <p:nvSpPr>
+          <p:cNvPr id="24" name="rotulo-supuesto"/>
+          <p:cNvSpPr/>
+          <p:nvPr/>
+        </p:nvSpPr>
+        <p:spPr>
+          <a:xfrm>
+            <a:off x="548640" y="4800600"/>
+            <a:ext cx="2377440" cy="292608"/>
+          </a:xfrm>
+          <a:prstGeom prst="roundRect">
+            <a:avLst>
+              <a:gd name="adj" fmla="val 50000"/>
+            </a:avLst>
+          </a:prstGeom>
+          <a:solidFill>
+            <a:srgbClr val="FFFFFF"/>
+          </a:solidFill>
+          <a:ln w="12700">
+            <a:solidFill>
+              <a:srgbClr val="F2545B"/>
+            </a:solidFill>
+            <a:prstDash val="solid"/>
+          </a:ln>
+        </p:spPr>
+      </p:sp>
+      <p:sp>
+        <p:nvSpPr>
+          <p:cNvPr id="25" name="Text 22"/>
+          <p:cNvSpPr txBox="1"/>
+          <p:nvPr/>
+        </p:nvSpPr>
+        <p:spPr>
+          <a:xfrm>
+            <a:off x="548640" y="4800600"/>
+            <a:ext cx="2377440" cy="292608"/>
+          </a:xfrm>
+          <a:prstGeom prst="rect">
+            <a:avLst/>
+          </a:prstGeom>
+          <a:noFill/>
+          <a:ln/>
+        </p:spPr>
+        <p:txBody>
+          <a:bodyPr wrap="square" lIns="0" tIns="0" rIns="0" bIns="0" rtlCol="0" anchor="ctr"/>
+          <a:lstStyle/>
+          <a:p>
+            <a:pPr algn="ctr" indent="0" marL="0">
+              <a:buNone/>
+            </a:pPr>
+            <a:r>
+              <a:rPr lang="en-US" sz="1000" b="1" spc="100" kern="0" dirty="0">
+                <a:solidFill>
+                  <a:srgbClr val="F2545B"/>
+                </a:solidFill>
+                <a:latin typeface="Calibri" pitchFamily="34" charset="0"/>
+                <a:ea typeface="Calibri" pitchFamily="34" charset="-122"/>
+                <a:cs typeface="Calibri" pitchFamily="34" charset="-120"/>
+              </a:rPr>
+              <a:t>SUPUESTO DEL EJEMPLO</a:t>
+            </a:r>
+            <a:endParaRPr lang="en-US" sz="1000" dirty="0"/>
+          </a:p>
+        </p:txBody>
+      </p:sp>
+      <p:sp>
+        <p:nvSpPr>
+          <p:cNvPr id="26" name="Text 23"/>
+          <p:cNvSpPr txBox="1"/>
+          <p:nvPr/>
+        </p:nvSpPr>
+        <p:spPr>
+          <a:xfrm>
+            <a:off x="548640" y="5166360"/>
+            <a:ext cx="2194560" cy="548640"/>
+          </a:xfrm>
+          <a:prstGeom prst="rect">
+            <a:avLst/>
+          </a:prstGeom>
+          <a:noFill/>
+          <a:ln/>
+        </p:spPr>
+        <p:txBody>
+          <a:bodyPr wrap="square" lIns="0" tIns="0" rIns="0" bIns="0" rtlCol="0" anchor="ctr"/>
+          <a:lstStyle/>
+          <a:p>
+            <a:pPr indent="0" marL="0">
+              <a:buNone/>
+            </a:pPr>
+            <a:r>
+              <a:rPr lang="en-US" sz="3400" b="1" dirty="0">
+                <a:solidFill>
+                  <a:srgbClr val="F2545B"/>
+                </a:solidFill>
+                <a:latin typeface="Cambria" pitchFamily="34" charset="0"/>
+                <a:ea typeface="Cambria" pitchFamily="34" charset="-122"/>
+                <a:cs typeface="Cambria" pitchFamily="34" charset="-120"/>
+              </a:rPr>
+              <a:t>5.000</a:t>
+            </a:r>
+            <a:endParaRPr lang="en-US" sz="3400" dirty="0"/>
+          </a:p>
+        </p:txBody>
+      </p:sp>
+      <p:sp>
+        <p:nvSpPr>
+          <p:cNvPr id="27" name="Text 24"/>
+          <p:cNvSpPr txBox="1"/>
+          <p:nvPr/>
+        </p:nvSpPr>
+        <p:spPr>
+          <a:xfrm>
+            <a:off x="548640" y="5687568"/>
+            <a:ext cx="2194560" cy="320040"/>
+          </a:xfrm>
+          <a:prstGeom prst="rect">
+            <a:avLst/>
+          </a:prstGeom>
+          <a:noFill/>
+          <a:ln/>
+        </p:spPr>
+        <p:txBody>
+          <a:bodyPr wrap="square" lIns="0" tIns="0" rIns="0" bIns="0" rtlCol="0" anchor="t"/>
+          <a:lstStyle/>
+          <a:p>
+            <a:pPr indent="0" marL="0">
+              <a:buNone/>
+            </a:pPr>
+            <a:r>
+              <a:rPr lang="en-US" sz="1300" dirty="0">
+                <a:solidFill>
+                  <a:srgbClr val="4A4560"/>
+                </a:solidFill>
+                <a:latin typeface="Calibri" pitchFamily="34" charset="0"/>
+                <a:ea typeface="Calibri" pitchFamily="34" charset="-122"/>
+                <a:cs typeface="Calibri" pitchFamily="34" charset="-120"/>
+              </a:rPr>
+              <a:t>alumnos a la vez a las 08:00</a:t>
+            </a:r>
+            <a:endParaRPr lang="en-US" sz="1300" dirty="0"/>
+          </a:p>
+        </p:txBody>
+      </p:sp>
+      <p:sp>
+        <p:nvSpPr>
+          <p:cNvPr id="28" name="Text 25"/>
+          <p:cNvSpPr txBox="1"/>
+          <p:nvPr/>
+        </p:nvSpPr>
+        <p:spPr>
+          <a:xfrm>
+            <a:off x="2926080" y="5166360"/>
+            <a:ext cx="2194560" cy="548640"/>
+          </a:xfrm>
+          <a:prstGeom prst="rect">
+            <a:avLst/>
+          </a:prstGeom>
+          <a:noFill/>
+          <a:ln/>
+        </p:spPr>
+        <p:txBody>
+          <a:bodyPr wrap="square" lIns="0" tIns="0" rIns="0" bIns="0" rtlCol="0" anchor="ctr"/>
+          <a:lstStyle/>
+          <a:p>
+            <a:pPr indent="0" marL="0">
+              <a:buNone/>
+            </a:pPr>
+            <a:r>
+              <a:rPr lang="en-US" sz="3400" b="1" dirty="0">
+                <a:solidFill>
+                  <a:srgbClr val="3B1F78"/>
+                </a:solidFill>
+                <a:latin typeface="Cambria" pitchFamily="34" charset="0"/>
+                <a:ea typeface="Cambria" pitchFamily="34" charset="-122"/>
+                <a:cs typeface="Cambria" pitchFamily="34" charset="-120"/>
+              </a:rPr>
+              <a:t>&lt; 100</a:t>
+            </a:r>
+            <a:endParaRPr lang="en-US" sz="3400" dirty="0"/>
+          </a:p>
+        </p:txBody>
+      </p:sp>
+      <p:sp>
+        <p:nvSpPr>
+          <p:cNvPr id="29" name="Text 26"/>
+          <p:cNvSpPr txBox="1"/>
+          <p:nvPr/>
+        </p:nvSpPr>
+        <p:spPr>
+          <a:xfrm>
+            <a:off x="2926080" y="5687568"/>
+            <a:ext cx="2194560" cy="320040"/>
+          </a:xfrm>
+          <a:prstGeom prst="rect">
+            <a:avLst/>
+          </a:prstGeom>
+          <a:noFill/>
+          <a:ln/>
+        </p:spPr>
+        <p:txBody>
+          <a:bodyPr wrap="square" lIns="0" tIns="0" rIns="0" bIns="0" rtlCol="0" anchor="t"/>
+          <a:lstStyle/>
+          <a:p>
+            <a:pPr indent="0" marL="0">
+              <a:buNone/>
+            </a:pPr>
+            <a:r>
+              <a:rPr lang="en-US" sz="1300" dirty="0">
+                <a:solidFill>
+                  <a:srgbClr val="4A4560"/>
+                </a:solidFill>
+                <a:latin typeface="Calibri" pitchFamily="34" charset="0"/>
+                <a:ea typeface="Calibri" pitchFamily="34" charset="-122"/>
+                <a:cs typeface="Calibri" pitchFamily="34" charset="-120"/>
+              </a:rPr>
+              <a:t>el resto del año</a:t>
+            </a:r>
+            <a:endParaRPr lang="en-US" sz="1300" dirty="0"/>
+          </a:p>
+        </p:txBody>
+      </p:sp>
+      <p:sp>
+        <p:nvSpPr>
+          <p:cNvPr id="30" name="Text 27"/>
+          <p:cNvSpPr txBox="1"/>
+          <p:nvPr/>
+        </p:nvSpPr>
+        <p:spPr>
+          <a:xfrm>
+            <a:off x="5623560" y="1600200"/>
+            <a:ext cx="6019495" cy="365760"/>
+          </a:xfrm>
+          <a:prstGeom prst="rect">
+            <a:avLst/>
+          </a:prstGeom>
+          <a:noFill/>
+          <a:ln/>
+        </p:spPr>
+        <p:txBody>
+          <a:bodyPr wrap="square" lIns="0" tIns="0" rIns="0" bIns="0" rtlCol="0" anchor="t"/>
+          <a:lstStyle/>
+          <a:p>
+            <a:pPr indent="0" marL="0">
+              <a:buNone/>
+            </a:pPr>
+            <a:r>
+              <a:rPr lang="en-US" sz="1700" b="1" dirty="0">
+                <a:solidFill>
+                  <a:srgbClr val="3B1F78"/>
+                </a:solidFill>
+                <a:latin typeface="Calibri" pitchFamily="34" charset="0"/>
+                <a:ea typeface="Calibri" pitchFamily="34" charset="-122"/>
+                <a:cs typeface="Calibri" pitchFamily="34" charset="-120"/>
+              </a:rPr>
+              <a:t>Pedidos por segundo el día de inscripción</a:t>
+            </a:r>
+            <a:endParaRPr lang="en-US" sz="1700" dirty="0"/>
+          </a:p>
+        </p:txBody>
+      </p:sp>
       <p:graphicFrame>
         <p:nvGraphicFramePr>
-          <p:cNvPr id="5" name="Chart 0" descr=""/>
+          <p:cNvPr id="31" name="Chart 0" descr=""/>
           <p:cNvGraphicFramePr/>
           <p:nvPr/>
         </p:nvGraphicFramePr>
         <p:xfrm>
-          <a:off x="548640" y="1554480"/>
-          <a:ext cx="7498080" cy="4343400"/>
+          <a:off x="5532120" y="2011680"/>
+          <a:ext cx="6110935" cy="3246120"/>
         </p:xfrm>
         <a:graphic xmlns:a="http://schemas.openxmlformats.org/drawingml/2006/main">
           <a:graphicData uri="http://schemas.openxmlformats.org/drawingml/2006/chart">
@@ -10368,41 +11096,36 @@
       </p:graphicFrame>
       <p:sp>
         <p:nvSpPr>
-          <p:cNvPr id="6" name="rotulo-supuesto"/>
-          <p:cNvSpPr/>
-          <p:nvPr/>
-        </p:nvSpPr>
-        <p:spPr>
-          <a:xfrm>
-            <a:off x="8412480" y="1600200"/>
-            <a:ext cx="2377440" cy="292608"/>
+          <p:cNvPr id="32" name="tarjeta"/>
+          <p:cNvSpPr/>
+          <p:nvPr/>
+        </p:nvSpPr>
+        <p:spPr>
+          <a:xfrm>
+            <a:off x="5623560" y="5394960"/>
+            <a:ext cx="6019495" cy="566928"/>
           </a:xfrm>
           <a:prstGeom prst="roundRect">
             <a:avLst>
-              <a:gd name="adj" fmla="val 50000"/>
+              <a:gd name="adj" fmla="val 16129"/>
             </a:avLst>
           </a:prstGeom>
           <a:solidFill>
-            <a:srgbClr val="FFFFFF"/>
-          </a:solidFill>
-          <a:ln w="12700">
-            <a:solidFill>
-              <a:srgbClr val="F2545B"/>
-            </a:solidFill>
-            <a:prstDash val="solid"/>
-          </a:ln>
-        </p:spPr>
-      </p:sp>
-      <p:sp>
-        <p:nvSpPr>
-          <p:cNvPr id="7" name="Text 3"/>
-          <p:cNvSpPr txBox="1"/>
-          <p:nvPr/>
-        </p:nvSpPr>
-        <p:spPr>
-          <a:xfrm>
-            <a:off x="8412480" y="1600200"/>
-            <a:ext cx="2377440" cy="292608"/>
+            <a:srgbClr val="F1EDFA"/>
+          </a:solidFill>
+          <a:ln/>
+        </p:spPr>
+      </p:sp>
+      <p:sp>
+        <p:nvSpPr>
+          <p:cNvPr id="33" name="Text 29"/>
+          <p:cNvSpPr txBox="1"/>
+          <p:nvPr/>
+        </p:nvSpPr>
+        <p:spPr>
+          <a:xfrm>
+            <a:off x="5852160" y="5394960"/>
+            <a:ext cx="5562295" cy="566928"/>
           </a:xfrm>
           <a:prstGeom prst="rect">
             <a:avLst/>
@@ -10414,216 +11137,35 @@
           <a:bodyPr wrap="square" lIns="0" tIns="0" rIns="0" bIns="0" rtlCol="0" anchor="ctr"/>
           <a:lstStyle/>
           <a:p>
-            <a:pPr algn="ctr" indent="0" marL="0">
-              <a:buNone/>
-            </a:pPr>
-            <a:r>
-              <a:rPr lang="en-US" sz="1000" b="1" spc="100" kern="0" dirty="0">
-                <a:solidFill>
-                  <a:srgbClr val="F2545B"/>
+            <a:pPr indent="0" marL="0">
+              <a:buNone/>
+            </a:pPr>
+            <a:r>
+              <a:rPr lang="en-US" sz="1500" b="1" dirty="0">
+                <a:solidFill>
+                  <a:srgbClr val="1E1433"/>
                 </a:solidFill>
                 <a:latin typeface="Calibri" pitchFamily="34" charset="0"/>
                 <a:ea typeface="Calibri" pitchFamily="34" charset="-122"/>
                 <a:cs typeface="Calibri" pitchFamily="34" charset="-120"/>
               </a:rPr>
-              <a:t>SUPUESTO DEL EJEMPLO</a:t>
-            </a:r>
-            <a:endParaRPr lang="en-US" sz="1000" dirty="0"/>
-          </a:p>
-        </p:txBody>
-      </p:sp>
-      <p:sp>
-        <p:nvSpPr>
-          <p:cNvPr id="8" name="Text 4"/>
-          <p:cNvSpPr txBox="1"/>
-          <p:nvPr/>
-        </p:nvSpPr>
-        <p:spPr>
-          <a:xfrm>
-            <a:off x="8412480" y="2057400"/>
-            <a:ext cx="3230575" cy="914400"/>
-          </a:xfrm>
-          <a:prstGeom prst="rect">
-            <a:avLst/>
-          </a:prstGeom>
-          <a:noFill/>
-          <a:ln/>
-        </p:spPr>
-        <p:txBody>
-          <a:bodyPr wrap="square" lIns="0" tIns="0" rIns="0" bIns="0" rtlCol="0" anchor="ctr"/>
-          <a:lstStyle/>
-          <a:p>
+              <a:t>A las 08:00 la demanda supera 5 veces la capacidad: </a:t>
+            </a:r>
             <a:pPr indent="0" marL="0">
               <a:buNone/>
             </a:pPr>
             <a:r>
-              <a:rPr lang="en-US" sz="6000" b="1" dirty="0">
+              <a:rPr lang="en-US" sz="1500" b="1" dirty="0">
                 <a:solidFill>
                   <a:srgbClr val="F2545B"/>
-                </a:solidFill>
-                <a:latin typeface="Cambria" pitchFamily="34" charset="0"/>
-                <a:ea typeface="Cambria" pitchFamily="34" charset="-122"/>
-                <a:cs typeface="Cambria" pitchFamily="34" charset="-120"/>
-              </a:rPr>
-              <a:t>5.000</a:t>
-            </a:r>
-            <a:endParaRPr lang="en-US" sz="6000" dirty="0"/>
-          </a:p>
-        </p:txBody>
-      </p:sp>
-      <p:sp>
-        <p:nvSpPr>
-          <p:cNvPr id="9" name="Text 5"/>
-          <p:cNvSpPr txBox="1"/>
-          <p:nvPr/>
-        </p:nvSpPr>
-        <p:spPr>
-          <a:xfrm>
-            <a:off x="8412480" y="2971800"/>
-            <a:ext cx="3230575" cy="685800"/>
-          </a:xfrm>
-          <a:prstGeom prst="rect">
-            <a:avLst/>
-          </a:prstGeom>
-          <a:noFill/>
-          <a:ln/>
-        </p:spPr>
-        <p:txBody>
-          <a:bodyPr wrap="square" lIns="0" tIns="0" rIns="0" bIns="0" rtlCol="0" anchor="t"/>
-          <a:lstStyle/>
-          <a:p>
-            <a:pPr indent="0" marL="0">
-              <a:buNone/>
-            </a:pPr>
-            <a:r>
-              <a:rPr lang="en-US" sz="1500" dirty="0">
-                <a:solidFill>
-                  <a:srgbClr val="4A4560"/>
                 </a:solidFill>
                 <a:latin typeface="Calibri" pitchFamily="34" charset="0"/>
                 <a:ea typeface="Calibri" pitchFamily="34" charset="-122"/>
                 <a:cs typeface="Calibri" pitchFamily="34" charset="-120"/>
               </a:rPr>
-              <a:t>alumnos a la vez el día que abre la inscripción a cursado</a:t>
+              <a:t>todo lo que no entra es un 503.</a:t>
             </a:r>
             <a:endParaRPr lang="en-US" sz="1500" dirty="0"/>
-          </a:p>
-        </p:txBody>
-      </p:sp>
-      <p:sp>
-        <p:nvSpPr>
-          <p:cNvPr id="10" name="Text 6"/>
-          <p:cNvSpPr txBox="1"/>
-          <p:nvPr/>
-        </p:nvSpPr>
-        <p:spPr>
-          <a:xfrm>
-            <a:off x="8412480" y="3840480"/>
-            <a:ext cx="3230575" cy="731520"/>
-          </a:xfrm>
-          <a:prstGeom prst="rect">
-            <a:avLst/>
-          </a:prstGeom>
-          <a:noFill/>
-          <a:ln/>
-        </p:spPr>
-        <p:txBody>
-          <a:bodyPr wrap="square" lIns="0" tIns="0" rIns="0" bIns="0" rtlCol="0" anchor="ctr"/>
-          <a:lstStyle/>
-          <a:p>
-            <a:pPr indent="0" marL="0">
-              <a:buNone/>
-            </a:pPr>
-            <a:r>
-              <a:rPr lang="en-US" sz="4000" b="1" dirty="0">
-                <a:solidFill>
-                  <a:srgbClr val="3B1F78"/>
-                </a:solidFill>
-                <a:latin typeface="Cambria" pitchFamily="34" charset="0"/>
-                <a:ea typeface="Cambria" pitchFamily="34" charset="-122"/>
-                <a:cs typeface="Cambria" pitchFamily="34" charset="-120"/>
-              </a:rPr>
-              <a:t>&lt; 100</a:t>
-            </a:r>
-            <a:endParaRPr lang="en-US" sz="4000" dirty="0"/>
-          </a:p>
-        </p:txBody>
-      </p:sp>
-      <p:sp>
-        <p:nvSpPr>
-          <p:cNvPr id="11" name="Text 7"/>
-          <p:cNvSpPr txBox="1"/>
-          <p:nvPr/>
-        </p:nvSpPr>
-        <p:spPr>
-          <a:xfrm>
-            <a:off x="8412480" y="4572000"/>
-            <a:ext cx="3230575" cy="365760"/>
-          </a:xfrm>
-          <a:prstGeom prst="rect">
-            <a:avLst/>
-          </a:prstGeom>
-          <a:noFill/>
-          <a:ln/>
-        </p:spPr>
-        <p:txBody>
-          <a:bodyPr wrap="square" lIns="0" tIns="0" rIns="0" bIns="0" rtlCol="0" anchor="t"/>
-          <a:lstStyle/>
-          <a:p>
-            <a:pPr indent="0" marL="0">
-              <a:buNone/>
-            </a:pPr>
-            <a:r>
-              <a:rPr lang="en-US" sz="1500" dirty="0">
-                <a:solidFill>
-                  <a:srgbClr val="4A4560"/>
-                </a:solidFill>
-                <a:latin typeface="Calibri" pitchFamily="34" charset="0"/>
-                <a:ea typeface="Calibri" pitchFamily="34" charset="-122"/>
-                <a:cs typeface="Calibri" pitchFamily="34" charset="-120"/>
-              </a:rPr>
-              <a:t>el resto del año</a:t>
-            </a:r>
-            <a:endParaRPr lang="en-US" sz="1500" dirty="0"/>
-          </a:p>
-        </p:txBody>
-      </p:sp>
-      <p:sp>
-        <p:nvSpPr>
-          <p:cNvPr id="12" name="Text 8"/>
-          <p:cNvSpPr txBox="1"/>
-          <p:nvPr/>
-        </p:nvSpPr>
-        <p:spPr>
-          <a:xfrm>
-            <a:off x="548640" y="6053328"/>
-            <a:ext cx="11094415" cy="274320"/>
-          </a:xfrm>
-          <a:prstGeom prst="rect">
-            <a:avLst/>
-          </a:prstGeom>
-          <a:noFill/>
-          <a:ln/>
-        </p:spPr>
-        <p:txBody>
-          <a:bodyPr wrap="square" lIns="0" tIns="0" rIns="0" bIns="0" rtlCol="0" anchor="t"/>
-          <a:lstStyle/>
-          <a:p>
-            <a:pPr indent="0" marL="0">
-              <a:buNone/>
-            </a:pPr>
-            <a:r>
-              <a:rPr lang="en-US" sz="1000" i="1" dirty="0">
-                <a:solidFill>
-                  <a:srgbClr val="7A7391"/>
-                </a:solidFill>
-                <a:latin typeface="Calibri" pitchFamily="34" charset="0"/>
-                <a:ea typeface="Calibri" pitchFamily="34" charset="-122"/>
-                <a:cs typeface="Calibri" pitchFamily="34" charset="-120"/>
-              </a:rPr>
-              <a:t>Escenario ilustrativo: los números del caso son supuestos para el ejemplo, no mediciones del SysAcad ni datos de la UTN.</a:t>
-            </a:r>
-            <a:endParaRPr lang="en-US" sz="1000" dirty="0"/>
           </a:p>
         </p:txBody>
       </p:sp>

</xml_diff>